<commit_message>
Cambiar la presentacion a paleta corporativa
Sustituye la paleta de madera (marron y ambar) por una empresarial: azul
marino, azul acero y grises, con rojo y verde reservados a las cifras que
deciden. Se anade un azul claro para los acentos que van sobre fondo
oscuro, donde el azul acero no contrastaba. Esquinas menos redondeadas.

Todos los pares de color superan 5,4:1 de contraste, muy por encima del
minimo de 4,5:1. Sin desbordes ni solapes; validate.py sin errores.
</commit_message>
<xml_diff>
--- a/Alcopalet_Defensa.pptx
+++ b/Alcopalet_Defensa.pptx
@@ -160,7 +160,7 @@
                 <a:pPr>
                   <a:defRPr b="0" i="0" strike="noStrike" sz="1300" u="none">
                     <a:solidFill>
-                      <a:srgbClr val="2B2118"/>
+                      <a:srgbClr val="12294A"/>
                     </a:solidFill>
                     <a:latin typeface="Calibri"/>
                   </a:defRPr>
@@ -192,7 +192,7 @@
             <c:bubble3D val="0"/>
             <c:spPr>
               <a:solidFill>
-                <a:srgbClr val="2E6F40"/>
+                <a:srgbClr val="1E6B3A"/>
               </a:solidFill>
               <a:effectLst/>
             </c:spPr>
@@ -238,7 +238,7 @@
               <a:pPr>
                 <a:defRPr b="0" i="0" strike="noStrike" sz="1300" u="none">
                   <a:solidFill>
-                    <a:srgbClr val="2B2118"/>
+                    <a:srgbClr val="12294A"/>
                   </a:solidFill>
                   <a:latin typeface="Calibri"/>
                 </a:defRPr>
@@ -286,7 +286,7 @@
             <a:pPr>
               <a:defRPr sz="1300" b="0" i="0" u="none" strike="noStrike">
                 <a:solidFill>
-                  <a:srgbClr val="2B2118"/>
+                  <a:srgbClr val="12294A"/>
                 </a:solidFill>
                 <a:latin typeface="Calibri"/>
               </a:defRPr>
@@ -340,7 +340,7 @@
             <a:pPr>
               <a:defRPr sz="1000" b="0" i="0" u="none" strike="noStrike">
                 <a:solidFill>
-                  <a:srgbClr val="6B6259"/>
+                  <a:srgbClr val="5A6472"/>
                 </a:solidFill>
                 <a:latin typeface="Calibri"/>
               </a:defRPr>
@@ -2094,7 +2094,7 @@
     <p:bg>
       <p:bgPr>
         <a:solidFill>
-          <a:srgbClr val="2B2118"/>
+          <a:srgbClr val="12294A"/>
         </a:solidFill>
       </p:bgPr>
     </p:bg>
@@ -2139,7 +2139,7 @@
             <a:r>
               <a:rPr lang="en-US" sz="1400" b="1" spc="500" kern="0" dirty="0">
                 <a:solidFill>
-                  <a:srgbClr val="C87F2A"/>
+                  <a:srgbClr val="8FB3DE"/>
                 </a:solidFill>
                 <a:latin typeface="Calibri" pitchFamily="34" charset="0"/>
                 <a:ea typeface="Calibri" pitchFamily="34" charset="-122"/>
@@ -2217,7 +2217,7 @@
             <a:r>
               <a:rPr lang="en-US" sz="2600" i="1" dirty="0">
                 <a:solidFill>
-                  <a:srgbClr val="EFD9B8"/>
+                  <a:srgbClr val="D6E2F0"/>
                 </a:solidFill>
                 <a:latin typeface="Cambria" pitchFamily="34" charset="0"/>
                 <a:ea typeface="Cambria" pitchFamily="34" charset="-122"/>
@@ -2244,7 +2244,7 @@
             <a:avLst/>
           </a:prstGeom>
           <a:solidFill>
-            <a:srgbClr val="C87F2A"/>
+            <a:srgbClr val="8FB3DE"/>
           </a:solidFill>
           <a:ln/>
         </p:spPr>
@@ -2315,7 +2315,7 @@
             <a:r>
               <a:rPr lang="en-US" sz="1200" dirty="0">
                 <a:solidFill>
-                  <a:srgbClr val="A79E93"/>
+                  <a:srgbClr val="98A2B0"/>
                 </a:solidFill>
                 <a:latin typeface="Calibri" pitchFamily="34" charset="0"/>
                 <a:ea typeface="Calibri" pitchFamily="34" charset="-122"/>
@@ -2379,7 +2379,7 @@
             <a:r>
               <a:rPr lang="en-US" sz="3200" b="1" dirty="0">
                 <a:solidFill>
-                  <a:srgbClr val="2B2118"/>
+                  <a:srgbClr val="12294A"/>
                 </a:solidFill>
                 <a:latin typeface="Cambria" pitchFamily="34" charset="0"/>
                 <a:ea typeface="Cambria" pitchFamily="34" charset="-122"/>
@@ -2418,7 +2418,7 @@
             <a:r>
               <a:rPr lang="en-US" sz="1400" dirty="0">
                 <a:solidFill>
-                  <a:srgbClr val="6B6259"/>
+                  <a:srgbClr val="5A6472"/>
                 </a:solidFill>
                 <a:latin typeface="Calibri" pitchFamily="34" charset="0"/>
                 <a:ea typeface="Calibri" pitchFamily="34" charset="-122"/>
@@ -2443,15 +2443,15 @@
           </a:xfrm>
           <a:prstGeom prst="roundRect">
             <a:avLst>
-              <a:gd name="adj" fmla="val 2553"/>
+              <a:gd name="adj" fmla="val 1277"/>
             </a:avLst>
           </a:prstGeom>
           <a:solidFill>
-            <a:srgbClr val="F7F5F2"/>
+            <a:srgbClr val="F4F6F9"/>
           </a:solidFill>
           <a:ln w="12700">
             <a:solidFill>
-              <a:srgbClr val="F7F5F2"/>
+              <a:srgbClr val="F4F6F9"/>
             </a:solidFill>
             <a:prstDash val="solid"/>
           </a:ln>
@@ -2484,7 +2484,7 @@
             <a:r>
               <a:rPr lang="en-US" sz="3200" b="1" dirty="0">
                 <a:solidFill>
-                  <a:srgbClr val="C87F2A"/>
+                  <a:srgbClr val="3E6CA3"/>
                 </a:solidFill>
                 <a:latin typeface="Cambria" pitchFamily="34" charset="0"/>
                 <a:ea typeface="Cambria" pitchFamily="34" charset="-122"/>
@@ -2523,7 +2523,7 @@
             <a:r>
               <a:rPr lang="en-US" sz="1400" b="1" dirty="0">
                 <a:solidFill>
-                  <a:srgbClr val="2B2118"/>
+                  <a:srgbClr val="12294A"/>
                 </a:solidFill>
                 <a:latin typeface="Calibri" pitchFamily="34" charset="0"/>
                 <a:ea typeface="Calibri" pitchFamily="34" charset="-122"/>
@@ -2565,7 +2565,7 @@
             <a:r>
               <a:rPr lang="en-US" sz="1200" dirty="0">
                 <a:solidFill>
-                  <a:srgbClr val="6B6259"/>
+                  <a:srgbClr val="5A6472"/>
                 </a:solidFill>
                 <a:latin typeface="Calibri" pitchFamily="34" charset="0"/>
                 <a:ea typeface="Calibri" pitchFamily="34" charset="-122"/>
@@ -2585,7 +2585,7 @@
             <a:r>
               <a:rPr lang="en-US" sz="1200" dirty="0">
                 <a:solidFill>
-                  <a:srgbClr val="6B6259"/>
+                  <a:srgbClr val="5A6472"/>
                 </a:solidFill>
                 <a:latin typeface="Calibri" pitchFamily="34" charset="0"/>
                 <a:ea typeface="Calibri" pitchFamily="34" charset="-122"/>
@@ -2610,15 +2610,15 @@
           </a:xfrm>
           <a:prstGeom prst="roundRect">
             <a:avLst>
-              <a:gd name="adj" fmla="val 2553"/>
+              <a:gd name="adj" fmla="val 1277"/>
             </a:avLst>
           </a:prstGeom>
           <a:solidFill>
-            <a:srgbClr val="F7F5F2"/>
+            <a:srgbClr val="F4F6F9"/>
           </a:solidFill>
           <a:ln w="12700">
             <a:solidFill>
-              <a:srgbClr val="F7F5F2"/>
+              <a:srgbClr val="F4F6F9"/>
             </a:solidFill>
             <a:prstDash val="solid"/>
           </a:ln>
@@ -2651,7 +2651,7 @@
             <a:r>
               <a:rPr lang="en-US" sz="3200" b="1" dirty="0">
                 <a:solidFill>
-                  <a:srgbClr val="C87F2A"/>
+                  <a:srgbClr val="3E6CA3"/>
                 </a:solidFill>
                 <a:latin typeface="Cambria" pitchFamily="34" charset="0"/>
                 <a:ea typeface="Cambria" pitchFamily="34" charset="-122"/>
@@ -2690,7 +2690,7 @@
             <a:r>
               <a:rPr lang="en-US" sz="1400" b="1" dirty="0">
                 <a:solidFill>
-                  <a:srgbClr val="2B2118"/>
+                  <a:srgbClr val="12294A"/>
                 </a:solidFill>
                 <a:latin typeface="Calibri" pitchFamily="34" charset="0"/>
                 <a:ea typeface="Calibri" pitchFamily="34" charset="-122"/>
@@ -2732,7 +2732,7 @@
             <a:r>
               <a:rPr lang="en-US" sz="1200" dirty="0">
                 <a:solidFill>
-                  <a:srgbClr val="6B6259"/>
+                  <a:srgbClr val="5A6472"/>
                 </a:solidFill>
                 <a:latin typeface="Calibri" pitchFamily="34" charset="0"/>
                 <a:ea typeface="Calibri" pitchFamily="34" charset="-122"/>
@@ -2752,7 +2752,7 @@
             <a:r>
               <a:rPr lang="en-US" sz="1200" dirty="0">
                 <a:solidFill>
-                  <a:srgbClr val="6B6259"/>
+                  <a:srgbClr val="5A6472"/>
                 </a:solidFill>
                 <a:latin typeface="Calibri" pitchFamily="34" charset="0"/>
                 <a:ea typeface="Calibri" pitchFamily="34" charset="-122"/>
@@ -2777,15 +2777,15 @@
           </a:xfrm>
           <a:prstGeom prst="roundRect">
             <a:avLst>
-              <a:gd name="adj" fmla="val 2553"/>
+              <a:gd name="adj" fmla="val 1277"/>
             </a:avLst>
           </a:prstGeom>
           <a:solidFill>
-            <a:srgbClr val="F7F5F2"/>
+            <a:srgbClr val="F4F6F9"/>
           </a:solidFill>
           <a:ln w="12700">
             <a:solidFill>
-              <a:srgbClr val="F7F5F2"/>
+              <a:srgbClr val="F4F6F9"/>
             </a:solidFill>
             <a:prstDash val="solid"/>
           </a:ln>
@@ -2818,7 +2818,7 @@
             <a:r>
               <a:rPr lang="en-US" sz="3200" b="1" dirty="0">
                 <a:solidFill>
-                  <a:srgbClr val="C87F2A"/>
+                  <a:srgbClr val="3E6CA3"/>
                 </a:solidFill>
                 <a:latin typeface="Cambria" pitchFamily="34" charset="0"/>
                 <a:ea typeface="Cambria" pitchFamily="34" charset="-122"/>
@@ -2857,7 +2857,7 @@
             <a:r>
               <a:rPr lang="en-US" sz="1400" b="1" dirty="0">
                 <a:solidFill>
-                  <a:srgbClr val="2B2118"/>
+                  <a:srgbClr val="12294A"/>
                 </a:solidFill>
                 <a:latin typeface="Calibri" pitchFamily="34" charset="0"/>
                 <a:ea typeface="Calibri" pitchFamily="34" charset="-122"/>
@@ -2899,7 +2899,7 @@
             <a:r>
               <a:rPr lang="en-US" sz="1200" dirty="0">
                 <a:solidFill>
-                  <a:srgbClr val="6B6259"/>
+                  <a:srgbClr val="5A6472"/>
                 </a:solidFill>
                 <a:latin typeface="Calibri" pitchFamily="34" charset="0"/>
                 <a:ea typeface="Calibri" pitchFamily="34" charset="-122"/>
@@ -2919,7 +2919,7 @@
             <a:r>
               <a:rPr lang="en-US" sz="1200" dirty="0">
                 <a:solidFill>
-                  <a:srgbClr val="6B6259"/>
+                  <a:srgbClr val="5A6472"/>
                 </a:solidFill>
                 <a:latin typeface="Calibri" pitchFamily="34" charset="0"/>
                 <a:ea typeface="Calibri" pitchFamily="34" charset="-122"/>
@@ -2944,15 +2944,15 @@
           </a:xfrm>
           <a:prstGeom prst="roundRect">
             <a:avLst>
-              <a:gd name="adj" fmla="val 4800"/>
+              <a:gd name="adj" fmla="val 2400"/>
             </a:avLst>
           </a:prstGeom>
           <a:solidFill>
-            <a:srgbClr val="2B2118"/>
+            <a:srgbClr val="12294A"/>
           </a:solidFill>
           <a:ln w="12700">
             <a:solidFill>
-              <a:srgbClr val="2B2118"/>
+              <a:srgbClr val="12294A"/>
             </a:solidFill>
             <a:prstDash val="solid"/>
           </a:ln>
@@ -3024,7 +3024,7 @@
             <a:r>
               <a:rPr lang="en-US" sz="1300" dirty="0">
                 <a:solidFill>
-                  <a:srgbClr val="EFD9B8"/>
+                  <a:srgbClr val="D6E2F0"/>
                 </a:solidFill>
                 <a:latin typeface="Calibri" pitchFamily="34" charset="0"/>
                 <a:ea typeface="Calibri" pitchFamily="34" charset="-122"/>
@@ -3063,7 +3063,7 @@
             <a:r>
               <a:rPr lang="en-US" sz="2600" strike="sngStrike" dirty="0">
                 <a:solidFill>
-                  <a:srgbClr val="8A8079"/>
+                  <a:srgbClr val="7C8899"/>
                 </a:solidFill>
                 <a:latin typeface="Cambria" pitchFamily="34" charset="0"/>
                 <a:ea typeface="Cambria" pitchFamily="34" charset="-122"/>
@@ -3102,7 +3102,7 @@
             <a:r>
               <a:rPr lang="en-US" sz="2000" dirty="0">
                 <a:solidFill>
-                  <a:srgbClr val="C87F2A"/>
+                  <a:srgbClr val="8FB3DE"/>
                 </a:solidFill>
                 <a:latin typeface="Calibri" pitchFamily="34" charset="0"/>
                 <a:ea typeface="Calibri" pitchFamily="34" charset="-122"/>
@@ -3180,7 +3180,7 @@
             <a:r>
               <a:rPr lang="en-US" sz="900" dirty="0">
                 <a:solidFill>
-                  <a:srgbClr val="A79E93"/>
+                  <a:srgbClr val="98A2B0"/>
                 </a:solidFill>
                 <a:latin typeface="Calibri" pitchFamily="34" charset="0"/>
                 <a:ea typeface="Calibri" pitchFamily="34" charset="-122"/>
@@ -3219,7 +3219,7 @@
             <a:r>
               <a:rPr lang="en-US" sz="900" dirty="0">
                 <a:solidFill>
-                  <a:srgbClr val="A79E93"/>
+                  <a:srgbClr val="98A2B0"/>
                 </a:solidFill>
                 <a:latin typeface="Calibri" pitchFamily="34" charset="0"/>
                 <a:ea typeface="Calibri" pitchFamily="34" charset="-122"/>
@@ -3283,7 +3283,7 @@
             <a:r>
               <a:rPr lang="en-US" sz="3200" b="1" dirty="0">
                 <a:solidFill>
-                  <a:srgbClr val="2B2118"/>
+                  <a:srgbClr val="12294A"/>
                 </a:solidFill>
                 <a:latin typeface="Cambria" pitchFamily="34" charset="0"/>
                 <a:ea typeface="Cambria" pitchFamily="34" charset="-122"/>
@@ -3322,7 +3322,7 @@
             <a:r>
               <a:rPr lang="en-US" sz="1400" dirty="0">
                 <a:solidFill>
-                  <a:srgbClr val="6B6259"/>
+                  <a:srgbClr val="5A6472"/>
                 </a:solidFill>
                 <a:latin typeface="Calibri" pitchFamily="34" charset="0"/>
                 <a:ea typeface="Calibri" pitchFamily="34" charset="-122"/>
@@ -3349,7 +3349,7 @@
             <a:avLst/>
           </a:prstGeom>
           <a:solidFill>
-            <a:srgbClr val="C87F2A"/>
+            <a:srgbClr val="3E6CA3"/>
           </a:solidFill>
           <a:ln/>
         </p:spPr>
@@ -3410,7 +3410,7 @@
           <a:noFill/>
           <a:ln w="25400">
             <a:solidFill>
-              <a:srgbClr val="EFD9B8"/>
+              <a:srgbClr val="D6E2F0"/>
             </a:solidFill>
             <a:prstDash val="solid"/>
           </a:ln>
@@ -3443,7 +3443,7 @@
             <a:r>
               <a:rPr lang="en-US" sz="1700" b="1" dirty="0">
                 <a:solidFill>
-                  <a:srgbClr val="2B2118"/>
+                  <a:srgbClr val="12294A"/>
                 </a:solidFill>
                 <a:latin typeface="Cambria" pitchFamily="34" charset="0"/>
                 <a:ea typeface="Cambria" pitchFamily="34" charset="-122"/>
@@ -3482,7 +3482,7 @@
             <a:r>
               <a:rPr lang="en-US" sz="1250" dirty="0">
                 <a:solidFill>
-                  <a:srgbClr val="6B6259"/>
+                  <a:srgbClr val="5A6472"/>
                 </a:solidFill>
                 <a:latin typeface="Calibri" pitchFamily="34" charset="0"/>
                 <a:ea typeface="Calibri" pitchFamily="34" charset="-122"/>
@@ -3509,7 +3509,7 @@
             <a:avLst/>
           </a:prstGeom>
           <a:solidFill>
-            <a:srgbClr val="C87F2A"/>
+            <a:srgbClr val="3E6CA3"/>
           </a:solidFill>
           <a:ln/>
         </p:spPr>
@@ -3570,7 +3570,7 @@
           <a:noFill/>
           <a:ln w="25400">
             <a:solidFill>
-              <a:srgbClr val="EFD9B8"/>
+              <a:srgbClr val="D6E2F0"/>
             </a:solidFill>
             <a:prstDash val="solid"/>
           </a:ln>
@@ -3603,7 +3603,7 @@
             <a:r>
               <a:rPr lang="en-US" sz="1700" b="1" dirty="0">
                 <a:solidFill>
-                  <a:srgbClr val="2B2118"/>
+                  <a:srgbClr val="12294A"/>
                 </a:solidFill>
                 <a:latin typeface="Cambria" pitchFamily="34" charset="0"/>
                 <a:ea typeface="Cambria" pitchFamily="34" charset="-122"/>
@@ -3642,7 +3642,7 @@
             <a:r>
               <a:rPr lang="en-US" sz="1250" dirty="0">
                 <a:solidFill>
-                  <a:srgbClr val="6B6259"/>
+                  <a:srgbClr val="5A6472"/>
                 </a:solidFill>
                 <a:latin typeface="Calibri" pitchFamily="34" charset="0"/>
                 <a:ea typeface="Calibri" pitchFamily="34" charset="-122"/>
@@ -3669,7 +3669,7 @@
             <a:avLst/>
           </a:prstGeom>
           <a:solidFill>
-            <a:srgbClr val="C87F2A"/>
+            <a:srgbClr val="3E6CA3"/>
           </a:solidFill>
           <a:ln/>
         </p:spPr>
@@ -3730,7 +3730,7 @@
           <a:noFill/>
           <a:ln w="25400">
             <a:solidFill>
-              <a:srgbClr val="EFD9B8"/>
+              <a:srgbClr val="D6E2F0"/>
             </a:solidFill>
             <a:prstDash val="solid"/>
           </a:ln>
@@ -3763,7 +3763,7 @@
             <a:r>
               <a:rPr lang="en-US" sz="1700" b="1" dirty="0">
                 <a:solidFill>
-                  <a:srgbClr val="2B2118"/>
+                  <a:srgbClr val="12294A"/>
                 </a:solidFill>
                 <a:latin typeface="Cambria" pitchFamily="34" charset="0"/>
                 <a:ea typeface="Cambria" pitchFamily="34" charset="-122"/>
@@ -3802,7 +3802,7 @@
             <a:r>
               <a:rPr lang="en-US" sz="1250" dirty="0">
                 <a:solidFill>
-                  <a:srgbClr val="6B6259"/>
+                  <a:srgbClr val="5A6472"/>
                 </a:solidFill>
                 <a:latin typeface="Calibri" pitchFamily="34" charset="0"/>
                 <a:ea typeface="Calibri" pitchFamily="34" charset="-122"/>
@@ -3829,7 +3829,7 @@
             <a:avLst/>
           </a:prstGeom>
           <a:solidFill>
-            <a:srgbClr val="C87F2A"/>
+            <a:srgbClr val="3E6CA3"/>
           </a:solidFill>
           <a:ln/>
         </p:spPr>
@@ -3890,7 +3890,7 @@
           <a:noFill/>
           <a:ln w="25400">
             <a:solidFill>
-              <a:srgbClr val="EFD9B8"/>
+              <a:srgbClr val="D6E2F0"/>
             </a:solidFill>
             <a:prstDash val="solid"/>
           </a:ln>
@@ -3923,7 +3923,7 @@
             <a:r>
               <a:rPr lang="en-US" sz="1700" b="1" dirty="0">
                 <a:solidFill>
-                  <a:srgbClr val="2B2118"/>
+                  <a:srgbClr val="12294A"/>
                 </a:solidFill>
                 <a:latin typeface="Cambria" pitchFamily="34" charset="0"/>
                 <a:ea typeface="Cambria" pitchFamily="34" charset="-122"/>
@@ -3962,7 +3962,7 @@
             <a:r>
               <a:rPr lang="en-US" sz="1250" dirty="0">
                 <a:solidFill>
-                  <a:srgbClr val="6B6259"/>
+                  <a:srgbClr val="5A6472"/>
                 </a:solidFill>
                 <a:latin typeface="Calibri" pitchFamily="34" charset="0"/>
                 <a:ea typeface="Calibri" pitchFamily="34" charset="-122"/>
@@ -3989,7 +3989,7 @@
             <a:avLst/>
           </a:prstGeom>
           <a:solidFill>
-            <a:srgbClr val="C87F2A"/>
+            <a:srgbClr val="3E6CA3"/>
           </a:solidFill>
           <a:ln/>
         </p:spPr>
@@ -4060,7 +4060,7 @@
             <a:r>
               <a:rPr lang="en-US" sz="1700" b="1" dirty="0">
                 <a:solidFill>
-                  <a:srgbClr val="2B2118"/>
+                  <a:srgbClr val="12294A"/>
                 </a:solidFill>
                 <a:latin typeface="Cambria" pitchFamily="34" charset="0"/>
                 <a:ea typeface="Cambria" pitchFamily="34" charset="-122"/>
@@ -4099,7 +4099,7 @@
             <a:r>
               <a:rPr lang="en-US" sz="1250" dirty="0">
                 <a:solidFill>
-                  <a:srgbClr val="6B6259"/>
+                  <a:srgbClr val="5A6472"/>
                 </a:solidFill>
                 <a:latin typeface="Calibri" pitchFamily="34" charset="0"/>
                 <a:ea typeface="Calibri" pitchFamily="34" charset="-122"/>
@@ -4138,7 +4138,7 @@
             <a:r>
               <a:rPr lang="en-US" sz="900" dirty="0">
                 <a:solidFill>
-                  <a:srgbClr val="A79E93"/>
+                  <a:srgbClr val="98A2B0"/>
                 </a:solidFill>
                 <a:latin typeface="Calibri" pitchFamily="34" charset="0"/>
                 <a:ea typeface="Calibri" pitchFamily="34" charset="-122"/>
@@ -4177,7 +4177,7 @@
             <a:r>
               <a:rPr lang="en-US" sz="900" dirty="0">
                 <a:solidFill>
-                  <a:srgbClr val="A79E93"/>
+                  <a:srgbClr val="98A2B0"/>
                 </a:solidFill>
                 <a:latin typeface="Calibri" pitchFamily="34" charset="0"/>
                 <a:ea typeface="Calibri" pitchFamily="34" charset="-122"/>
@@ -4203,7 +4203,7 @@
     <p:bg>
       <p:bgPr>
         <a:solidFill>
-          <a:srgbClr val="2B2118"/>
+          <a:srgbClr val="12294A"/>
         </a:solidFill>
       </p:bgPr>
     </p:bg>
@@ -4248,7 +4248,7 @@
             <a:r>
               <a:rPr lang="en-US" sz="1300" b="1" spc="500" kern="0" dirty="0">
                 <a:solidFill>
-                  <a:srgbClr val="C87F2A"/>
+                  <a:srgbClr val="8FB3DE"/>
                 </a:solidFill>
                 <a:latin typeface="Calibri" pitchFamily="34" charset="0"/>
                 <a:ea typeface="Calibri" pitchFamily="34" charset="-122"/>
@@ -4329,7 +4329,7 @@
             <a:r>
               <a:rPr lang="en-US" sz="1500" dirty="0">
                 <a:solidFill>
-                  <a:srgbClr val="EFD9B8"/>
+                  <a:srgbClr val="D6E2F0"/>
                 </a:solidFill>
                 <a:latin typeface="Calibri" pitchFamily="34" charset="0"/>
                 <a:ea typeface="Calibri" pitchFamily="34" charset="-122"/>
@@ -4356,7 +4356,7 @@
             <a:avLst/>
           </a:prstGeom>
           <a:solidFill>
-            <a:srgbClr val="C87F2A"/>
+            <a:srgbClr val="8FB3DE"/>
           </a:solidFill>
           <a:ln/>
         </p:spPr>
@@ -4427,7 +4427,7 @@
             <a:r>
               <a:rPr lang="en-US" sz="1400" dirty="0">
                 <a:solidFill>
-                  <a:srgbClr val="EFD9B8"/>
+                  <a:srgbClr val="D6E2F0"/>
                 </a:solidFill>
                 <a:latin typeface="Calibri" pitchFamily="34" charset="0"/>
                 <a:ea typeface="Calibri" pitchFamily="34" charset="-122"/>
@@ -4454,7 +4454,7 @@
             <a:avLst/>
           </a:prstGeom>
           <a:solidFill>
-            <a:srgbClr val="C87F2A"/>
+            <a:srgbClr val="8FB3DE"/>
           </a:solidFill>
           <a:ln/>
         </p:spPr>
@@ -4525,7 +4525,7 @@
             <a:r>
               <a:rPr lang="en-US" sz="1400" dirty="0">
                 <a:solidFill>
-                  <a:srgbClr val="EFD9B8"/>
+                  <a:srgbClr val="D6E2F0"/>
                 </a:solidFill>
                 <a:latin typeface="Calibri" pitchFamily="34" charset="0"/>
                 <a:ea typeface="Calibri" pitchFamily="34" charset="-122"/>
@@ -4552,7 +4552,7 @@
             <a:avLst/>
           </a:prstGeom>
           <a:solidFill>
-            <a:srgbClr val="C87F2A"/>
+            <a:srgbClr val="8FB3DE"/>
           </a:solidFill>
           <a:ln/>
         </p:spPr>
@@ -4623,7 +4623,7 @@
             <a:r>
               <a:rPr lang="en-US" sz="1400" dirty="0">
                 <a:solidFill>
-                  <a:srgbClr val="EFD9B8"/>
+                  <a:srgbClr val="D6E2F0"/>
                 </a:solidFill>
                 <a:latin typeface="Calibri" pitchFamily="34" charset="0"/>
                 <a:ea typeface="Calibri" pitchFamily="34" charset="-122"/>
@@ -4662,7 +4662,7 @@
             <a:r>
               <a:rPr lang="en-US" sz="1200" dirty="0">
                 <a:solidFill>
-                  <a:srgbClr val="8A8079"/>
+                  <a:srgbClr val="7C8899"/>
                 </a:solidFill>
                 <a:latin typeface="Calibri" pitchFamily="34" charset="0"/>
                 <a:ea typeface="Calibri" pitchFamily="34" charset="-122"/>
@@ -4726,7 +4726,7 @@
             <a:r>
               <a:rPr lang="en-US" sz="3200" b="1" dirty="0">
                 <a:solidFill>
-                  <a:srgbClr val="2B2118"/>
+                  <a:srgbClr val="12294A"/>
                 </a:solidFill>
                 <a:latin typeface="Cambria" pitchFamily="34" charset="0"/>
                 <a:ea typeface="Cambria" pitchFamily="34" charset="-122"/>
@@ -4765,7 +4765,7 @@
             <a:r>
               <a:rPr lang="en-US" sz="1400" dirty="0">
                 <a:solidFill>
-                  <a:srgbClr val="6B6259"/>
+                  <a:srgbClr val="5A6472"/>
                 </a:solidFill>
                 <a:latin typeface="Calibri" pitchFamily="34" charset="0"/>
                 <a:ea typeface="Calibri" pitchFamily="34" charset="-122"/>
@@ -4790,15 +4790,15 @@
           </a:xfrm>
           <a:prstGeom prst="roundRect">
             <a:avLst>
-              <a:gd name="adj" fmla="val 1829"/>
+              <a:gd name="adj" fmla="val 915"/>
             </a:avLst>
           </a:prstGeom>
           <a:solidFill>
-            <a:srgbClr val="F7F5F2"/>
+            <a:srgbClr val="F4F6F9"/>
           </a:solidFill>
           <a:ln w="12700">
             <a:solidFill>
-              <a:srgbClr val="F7F5F2"/>
+              <a:srgbClr val="F4F6F9"/>
             </a:solidFill>
             <a:prstDash val="solid"/>
           </a:ln>
@@ -4819,7 +4819,7 @@
             <a:avLst/>
           </a:prstGeom>
           <a:solidFill>
-            <a:srgbClr val="C87F2A"/>
+            <a:srgbClr val="3E6CA3"/>
           </a:solidFill>
           <a:ln/>
         </p:spPr>
@@ -4890,7 +4890,7 @@
             <a:r>
               <a:rPr lang="en-US" sz="1800" b="1" dirty="0">
                 <a:solidFill>
-                  <a:srgbClr val="2B2118"/>
+                  <a:srgbClr val="12294A"/>
                 </a:solidFill>
                 <a:latin typeface="Cambria" pitchFamily="34" charset="0"/>
                 <a:ea typeface="Cambria" pitchFamily="34" charset="-122"/>
@@ -4932,7 +4932,7 @@
             <a:r>
               <a:rPr lang="en-US" sz="1300" dirty="0">
                 <a:solidFill>
-                  <a:srgbClr val="6B6259"/>
+                  <a:srgbClr val="5A6472"/>
                 </a:solidFill>
                 <a:latin typeface="Calibri" pitchFamily="34" charset="0"/>
                 <a:ea typeface="Calibri" pitchFamily="34" charset="-122"/>
@@ -4952,7 +4952,7 @@
             <a:r>
               <a:rPr lang="en-US" sz="1300" dirty="0">
                 <a:solidFill>
-                  <a:srgbClr val="6B6259"/>
+                  <a:srgbClr val="5A6472"/>
                 </a:solidFill>
                 <a:latin typeface="Calibri" pitchFamily="34" charset="0"/>
                 <a:ea typeface="Calibri" pitchFamily="34" charset="-122"/>
@@ -4991,7 +4991,7 @@
             <a:r>
               <a:rPr lang="en-US" sz="1100" b="1" spc="100" kern="0" dirty="0">
                 <a:solidFill>
-                  <a:srgbClr val="C87F2A"/>
+                  <a:srgbClr val="3E6CA3"/>
                 </a:solidFill>
                 <a:latin typeface="Calibri" pitchFamily="34" charset="0"/>
                 <a:ea typeface="Calibri" pitchFamily="34" charset="-122"/>
@@ -5016,15 +5016,15 @@
           </a:xfrm>
           <a:prstGeom prst="roundRect">
             <a:avLst>
-              <a:gd name="adj" fmla="val 1829"/>
+              <a:gd name="adj" fmla="val 915"/>
             </a:avLst>
           </a:prstGeom>
           <a:solidFill>
-            <a:srgbClr val="F7F5F2"/>
+            <a:srgbClr val="F4F6F9"/>
           </a:solidFill>
           <a:ln w="12700">
             <a:solidFill>
-              <a:srgbClr val="F7F5F2"/>
+              <a:srgbClr val="F4F6F9"/>
             </a:solidFill>
             <a:prstDash val="solid"/>
           </a:ln>
@@ -5045,7 +5045,7 @@
             <a:avLst/>
           </a:prstGeom>
           <a:solidFill>
-            <a:srgbClr val="C87F2A"/>
+            <a:srgbClr val="3E6CA3"/>
           </a:solidFill>
           <a:ln/>
         </p:spPr>
@@ -5116,7 +5116,7 @@
             <a:r>
               <a:rPr lang="en-US" sz="1800" b="1" dirty="0">
                 <a:solidFill>
-                  <a:srgbClr val="2B2118"/>
+                  <a:srgbClr val="12294A"/>
                 </a:solidFill>
                 <a:latin typeface="Cambria" pitchFamily="34" charset="0"/>
                 <a:ea typeface="Cambria" pitchFamily="34" charset="-122"/>
@@ -5158,7 +5158,7 @@
             <a:r>
               <a:rPr lang="en-US" sz="1300" dirty="0">
                 <a:solidFill>
-                  <a:srgbClr val="6B6259"/>
+                  <a:srgbClr val="5A6472"/>
                 </a:solidFill>
                 <a:latin typeface="Calibri" pitchFamily="34" charset="0"/>
                 <a:ea typeface="Calibri" pitchFamily="34" charset="-122"/>
@@ -5178,7 +5178,7 @@
             <a:r>
               <a:rPr lang="en-US" sz="1300" dirty="0">
                 <a:solidFill>
-                  <a:srgbClr val="6B6259"/>
+                  <a:srgbClr val="5A6472"/>
                 </a:solidFill>
                 <a:latin typeface="Calibri" pitchFamily="34" charset="0"/>
                 <a:ea typeface="Calibri" pitchFamily="34" charset="-122"/>
@@ -5217,7 +5217,7 @@
             <a:r>
               <a:rPr lang="en-US" sz="1100" b="1" spc="100" kern="0" dirty="0">
                 <a:solidFill>
-                  <a:srgbClr val="C87F2A"/>
+                  <a:srgbClr val="3E6CA3"/>
                 </a:solidFill>
                 <a:latin typeface="Calibri" pitchFamily="34" charset="0"/>
                 <a:ea typeface="Calibri" pitchFamily="34" charset="-122"/>
@@ -5242,15 +5242,15 @@
           </a:xfrm>
           <a:prstGeom prst="roundRect">
             <a:avLst>
-              <a:gd name="adj" fmla="val 1829"/>
+              <a:gd name="adj" fmla="val 915"/>
             </a:avLst>
           </a:prstGeom>
           <a:solidFill>
-            <a:srgbClr val="F7F5F2"/>
+            <a:srgbClr val="F4F6F9"/>
           </a:solidFill>
           <a:ln w="12700">
             <a:solidFill>
-              <a:srgbClr val="F7F5F2"/>
+              <a:srgbClr val="F4F6F9"/>
             </a:solidFill>
             <a:prstDash val="solid"/>
           </a:ln>
@@ -5271,7 +5271,7 @@
             <a:avLst/>
           </a:prstGeom>
           <a:solidFill>
-            <a:srgbClr val="C87F2A"/>
+            <a:srgbClr val="3E6CA3"/>
           </a:solidFill>
           <a:ln/>
         </p:spPr>
@@ -5342,7 +5342,7 @@
             <a:r>
               <a:rPr lang="en-US" sz="1800" b="1" dirty="0">
                 <a:solidFill>
-                  <a:srgbClr val="2B2118"/>
+                  <a:srgbClr val="12294A"/>
                 </a:solidFill>
                 <a:latin typeface="Cambria" pitchFamily="34" charset="0"/>
                 <a:ea typeface="Cambria" pitchFamily="34" charset="-122"/>
@@ -5384,7 +5384,7 @@
             <a:r>
               <a:rPr lang="en-US" sz="1300" dirty="0">
                 <a:solidFill>
-                  <a:srgbClr val="6B6259"/>
+                  <a:srgbClr val="5A6472"/>
                 </a:solidFill>
                 <a:latin typeface="Calibri" pitchFamily="34" charset="0"/>
                 <a:ea typeface="Calibri" pitchFamily="34" charset="-122"/>
@@ -5404,7 +5404,7 @@
             <a:r>
               <a:rPr lang="en-US" sz="1300" dirty="0">
                 <a:solidFill>
-                  <a:srgbClr val="6B6259"/>
+                  <a:srgbClr val="5A6472"/>
                 </a:solidFill>
                 <a:latin typeface="Calibri" pitchFamily="34" charset="0"/>
                 <a:ea typeface="Calibri" pitchFamily="34" charset="-122"/>
@@ -5443,7 +5443,7 @@
             <a:r>
               <a:rPr lang="en-US" sz="1100" b="1" spc="100" kern="0" dirty="0">
                 <a:solidFill>
-                  <a:srgbClr val="C87F2A"/>
+                  <a:srgbClr val="3E6CA3"/>
                 </a:solidFill>
                 <a:latin typeface="Calibri" pitchFamily="34" charset="0"/>
                 <a:ea typeface="Calibri" pitchFamily="34" charset="-122"/>
@@ -5482,7 +5482,7 @@
             <a:r>
               <a:rPr lang="en-US" sz="1800" i="1" dirty="0">
                 <a:solidFill>
-                  <a:srgbClr val="2B2118"/>
+                  <a:srgbClr val="12294A"/>
                 </a:solidFill>
                 <a:latin typeface="Cambria" pitchFamily="34" charset="0"/>
                 <a:ea typeface="Cambria" pitchFamily="34" charset="-122"/>
@@ -5521,7 +5521,7 @@
             <a:r>
               <a:rPr lang="en-US" sz="900" dirty="0">
                 <a:solidFill>
-                  <a:srgbClr val="A79E93"/>
+                  <a:srgbClr val="98A2B0"/>
                 </a:solidFill>
                 <a:latin typeface="Calibri" pitchFamily="34" charset="0"/>
                 <a:ea typeface="Calibri" pitchFamily="34" charset="-122"/>
@@ -5560,7 +5560,7 @@
             <a:r>
               <a:rPr lang="en-US" sz="900" dirty="0">
                 <a:solidFill>
-                  <a:srgbClr val="A79E93"/>
+                  <a:srgbClr val="98A2B0"/>
                 </a:solidFill>
                 <a:latin typeface="Calibri" pitchFamily="34" charset="0"/>
                 <a:ea typeface="Calibri" pitchFamily="34" charset="-122"/>
@@ -5624,7 +5624,7 @@
             <a:r>
               <a:rPr lang="en-US" sz="3200" b="1" dirty="0">
                 <a:solidFill>
-                  <a:srgbClr val="2B2118"/>
+                  <a:srgbClr val="12294A"/>
                 </a:solidFill>
                 <a:latin typeface="Cambria" pitchFamily="34" charset="0"/>
                 <a:ea typeface="Cambria" pitchFamily="34" charset="-122"/>
@@ -5663,7 +5663,7 @@
             <a:r>
               <a:rPr lang="en-US" sz="1400" dirty="0">
                 <a:solidFill>
-                  <a:srgbClr val="6B6259"/>
+                  <a:srgbClr val="5A6472"/>
                 </a:solidFill>
                 <a:latin typeface="Calibri" pitchFamily="34" charset="0"/>
                 <a:ea typeface="Calibri" pitchFamily="34" charset="-122"/>
@@ -5702,7 +5702,7 @@
             <a:r>
               <a:rPr lang="en-US" sz="1400" dirty="0">
                 <a:solidFill>
-                  <a:srgbClr val="6B6259"/>
+                  <a:srgbClr val="5A6472"/>
                 </a:solidFill>
                 <a:latin typeface="Calibri" pitchFamily="34" charset="0"/>
                 <a:ea typeface="Calibri" pitchFamily="34" charset="-122"/>
@@ -5741,7 +5741,7 @@
             <a:r>
               <a:rPr lang="en-US" sz="1400" dirty="0">
                 <a:solidFill>
-                  <a:srgbClr val="2B2118"/>
+                  <a:srgbClr val="12294A"/>
                 </a:solidFill>
                 <a:latin typeface="Calibri" pitchFamily="34" charset="0"/>
                 <a:ea typeface="Calibri" pitchFamily="34" charset="-122"/>
@@ -5780,7 +5780,7 @@
             <a:r>
               <a:rPr lang="en-US" sz="1400" dirty="0">
                 <a:solidFill>
-                  <a:srgbClr val="6B6259"/>
+                  <a:srgbClr val="5A6472"/>
                 </a:solidFill>
                 <a:latin typeface="Calibri" pitchFamily="34" charset="0"/>
                 <a:ea typeface="Calibri" pitchFamily="34" charset="-122"/>
@@ -5819,7 +5819,7 @@
             <a:r>
               <a:rPr lang="en-US" sz="1400" dirty="0">
                 <a:solidFill>
-                  <a:srgbClr val="2B2118"/>
+                  <a:srgbClr val="12294A"/>
                 </a:solidFill>
                 <a:latin typeface="Calibri" pitchFamily="34" charset="0"/>
                 <a:ea typeface="Calibri" pitchFamily="34" charset="-122"/>
@@ -5858,7 +5858,7 @@
             <a:r>
               <a:rPr lang="en-US" sz="1400" dirty="0">
                 <a:solidFill>
-                  <a:srgbClr val="6B6259"/>
+                  <a:srgbClr val="5A6472"/>
                 </a:solidFill>
                 <a:latin typeface="Calibri" pitchFamily="34" charset="0"/>
                 <a:ea typeface="Calibri" pitchFamily="34" charset="-122"/>
@@ -5897,7 +5897,7 @@
             <a:r>
               <a:rPr lang="en-US" sz="1400" dirty="0">
                 <a:solidFill>
-                  <a:srgbClr val="2B2118"/>
+                  <a:srgbClr val="12294A"/>
                 </a:solidFill>
                 <a:latin typeface="Calibri" pitchFamily="34" charset="0"/>
                 <a:ea typeface="Calibri" pitchFamily="34" charset="-122"/>
@@ -5936,7 +5936,7 @@
             <a:r>
               <a:rPr lang="en-US" sz="1400" dirty="0">
                 <a:solidFill>
-                  <a:srgbClr val="6B6259"/>
+                  <a:srgbClr val="5A6472"/>
                 </a:solidFill>
                 <a:latin typeface="Calibri" pitchFamily="34" charset="0"/>
                 <a:ea typeface="Calibri" pitchFamily="34" charset="-122"/>
@@ -5975,7 +5975,7 @@
             <a:r>
               <a:rPr lang="en-US" sz="1400" dirty="0">
                 <a:solidFill>
-                  <a:srgbClr val="2B2118"/>
+                  <a:srgbClr val="12294A"/>
                 </a:solidFill>
                 <a:latin typeface="Calibri" pitchFamily="34" charset="0"/>
                 <a:ea typeface="Calibri" pitchFamily="34" charset="-122"/>
@@ -6014,7 +6014,7 @@
             <a:r>
               <a:rPr lang="en-US" sz="1400" dirty="0">
                 <a:solidFill>
-                  <a:srgbClr val="6B6259"/>
+                  <a:srgbClr val="5A6472"/>
                 </a:solidFill>
                 <a:latin typeface="Calibri" pitchFamily="34" charset="0"/>
                 <a:ea typeface="Calibri" pitchFamily="34" charset="-122"/>
@@ -6053,7 +6053,7 @@
             <a:r>
               <a:rPr lang="en-US" sz="1400" dirty="0">
                 <a:solidFill>
-                  <a:srgbClr val="2B2118"/>
+                  <a:srgbClr val="12294A"/>
                 </a:solidFill>
                 <a:latin typeface="Calibri" pitchFamily="34" charset="0"/>
                 <a:ea typeface="Calibri" pitchFamily="34" charset="-122"/>
@@ -6078,15 +6078,15 @@
           </a:xfrm>
           <a:prstGeom prst="roundRect">
             <a:avLst>
-              <a:gd name="adj" fmla="val 13043"/>
+              <a:gd name="adj" fmla="val 6522"/>
             </a:avLst>
           </a:prstGeom>
           <a:solidFill>
-            <a:srgbClr val="EFD9B8"/>
+            <a:srgbClr val="D6E2F0"/>
           </a:solidFill>
           <a:ln w="12700">
             <a:solidFill>
-              <a:srgbClr val="EFD9B8"/>
+              <a:srgbClr val="D6E2F0"/>
             </a:solidFill>
             <a:prstDash val="solid"/>
           </a:ln>
@@ -6119,7 +6119,7 @@
             <a:r>
               <a:rPr lang="en-US" sz="1400" b="1" dirty="0">
                 <a:solidFill>
-                  <a:srgbClr val="2B2118"/>
+                  <a:srgbClr val="12294A"/>
                 </a:solidFill>
                 <a:latin typeface="Calibri" pitchFamily="34" charset="0"/>
                 <a:ea typeface="Calibri" pitchFamily="34" charset="-122"/>
@@ -6158,7 +6158,7 @@
             <a:r>
               <a:rPr lang="en-US" sz="1400" b="1" dirty="0">
                 <a:solidFill>
-                  <a:srgbClr val="2B2118"/>
+                  <a:srgbClr val="12294A"/>
                 </a:solidFill>
                 <a:latin typeface="Calibri" pitchFamily="34" charset="0"/>
                 <a:ea typeface="Calibri" pitchFamily="34" charset="-122"/>
@@ -6183,15 +6183,15 @@
           </a:xfrm>
           <a:prstGeom prst="roundRect">
             <a:avLst>
-              <a:gd name="adj" fmla="val 2069"/>
+              <a:gd name="adj" fmla="val 1034"/>
             </a:avLst>
           </a:prstGeom>
           <a:solidFill>
-            <a:srgbClr val="2B2118"/>
+            <a:srgbClr val="12294A"/>
           </a:solidFill>
           <a:ln w="12700">
             <a:solidFill>
-              <a:srgbClr val="2B2118"/>
+              <a:srgbClr val="12294A"/>
             </a:solidFill>
             <a:prstDash val="solid"/>
           </a:ln>
@@ -6224,7 +6224,7 @@
             <a:r>
               <a:rPr lang="en-US" sz="1200" b="1" spc="300" kern="0" dirty="0">
                 <a:solidFill>
-                  <a:srgbClr val="C87F2A"/>
+                  <a:srgbClr val="8FB3DE"/>
                 </a:solidFill>
                 <a:latin typeface="Calibri" pitchFamily="34" charset="0"/>
                 <a:ea typeface="Calibri" pitchFamily="34" charset="-122"/>
@@ -6263,7 +6263,7 @@
             <a:r>
               <a:rPr lang="en-US" sz="6200" b="1" dirty="0">
                 <a:solidFill>
-                  <a:srgbClr val="FF7B6B"/>
+                  <a:srgbClr val="FF8A80"/>
                 </a:solidFill>
                 <a:latin typeface="Cambria" pitchFamily="34" charset="0"/>
                 <a:ea typeface="Cambria" pitchFamily="34" charset="-122"/>
@@ -6305,7 +6305,7 @@
             <a:r>
               <a:rPr lang="en-US" sz="1300" dirty="0">
                 <a:solidFill>
-                  <a:srgbClr val="EFD9B8"/>
+                  <a:srgbClr val="D6E2F0"/>
                 </a:solidFill>
                 <a:latin typeface="Calibri" pitchFamily="34" charset="0"/>
                 <a:ea typeface="Calibri" pitchFamily="34" charset="-122"/>
@@ -6325,7 +6325,7 @@
             <a:r>
               <a:rPr lang="en-US" sz="1300" dirty="0">
                 <a:solidFill>
-                  <a:srgbClr val="EFD9B8"/>
+                  <a:srgbClr val="D6E2F0"/>
                 </a:solidFill>
                 <a:latin typeface="Calibri" pitchFamily="34" charset="0"/>
                 <a:ea typeface="Calibri" pitchFamily="34" charset="-122"/>
@@ -6364,7 +6364,7 @@
             <a:r>
               <a:rPr lang="en-US" sz="1400" dirty="0">
                 <a:solidFill>
-                  <a:srgbClr val="6B6259"/>
+                  <a:srgbClr val="5A6472"/>
                 </a:solidFill>
                 <a:latin typeface="Calibri" pitchFamily="34" charset="0"/>
                 <a:ea typeface="Calibri" pitchFamily="34" charset="-122"/>
@@ -6403,7 +6403,7 @@
             <a:r>
               <a:rPr lang="en-US" sz="900" dirty="0">
                 <a:solidFill>
-                  <a:srgbClr val="A79E93"/>
+                  <a:srgbClr val="98A2B0"/>
                 </a:solidFill>
                 <a:latin typeface="Calibri" pitchFamily="34" charset="0"/>
                 <a:ea typeface="Calibri" pitchFamily="34" charset="-122"/>
@@ -6442,7 +6442,7 @@
             <a:r>
               <a:rPr lang="en-US" sz="900" dirty="0">
                 <a:solidFill>
-                  <a:srgbClr val="A79E93"/>
+                  <a:srgbClr val="98A2B0"/>
                 </a:solidFill>
                 <a:latin typeface="Calibri" pitchFamily="34" charset="0"/>
                 <a:ea typeface="Calibri" pitchFamily="34" charset="-122"/>
@@ -6506,7 +6506,7 @@
             <a:r>
               <a:rPr lang="en-US" sz="3200" b="1" dirty="0">
                 <a:solidFill>
-                  <a:srgbClr val="2B2118"/>
+                  <a:srgbClr val="12294A"/>
                 </a:solidFill>
                 <a:latin typeface="Cambria" pitchFamily="34" charset="0"/>
                 <a:ea typeface="Cambria" pitchFamily="34" charset="-122"/>
@@ -6545,7 +6545,7 @@
             <a:r>
               <a:rPr lang="en-US" sz="1400" dirty="0">
                 <a:solidFill>
-                  <a:srgbClr val="6B6259"/>
+                  <a:srgbClr val="5A6472"/>
                 </a:solidFill>
                 <a:latin typeface="Calibri" pitchFamily="34" charset="0"/>
                 <a:ea typeface="Calibri" pitchFamily="34" charset="-122"/>
@@ -6570,15 +6570,15 @@
           </a:xfrm>
           <a:prstGeom prst="roundRect">
             <a:avLst>
-              <a:gd name="adj" fmla="val 9677"/>
+              <a:gd name="adj" fmla="val 4839"/>
             </a:avLst>
           </a:prstGeom>
           <a:solidFill>
-            <a:srgbClr val="F7F5F2"/>
+            <a:srgbClr val="F4F6F9"/>
           </a:solidFill>
           <a:ln w="12700">
             <a:solidFill>
-              <a:srgbClr val="F7F5F2"/>
+              <a:srgbClr val="F4F6F9"/>
             </a:solidFill>
             <a:prstDash val="solid"/>
           </a:ln>
@@ -6611,7 +6611,7 @@
             <a:r>
               <a:rPr lang="en-US" sz="1400" b="1" dirty="0">
                 <a:solidFill>
-                  <a:srgbClr val="2B2118"/>
+                  <a:srgbClr val="12294A"/>
                 </a:solidFill>
                 <a:latin typeface="Calibri" pitchFamily="34" charset="0"/>
                 <a:ea typeface="Calibri" pitchFamily="34" charset="-122"/>
@@ -6650,7 +6650,7 @@
             <a:r>
               <a:rPr lang="en-US" sz="1100" dirty="0">
                 <a:solidFill>
-                  <a:srgbClr val="6B6259"/>
+                  <a:srgbClr val="5A6472"/>
                 </a:solidFill>
                 <a:latin typeface="Calibri" pitchFamily="34" charset="0"/>
                 <a:ea typeface="Calibri" pitchFamily="34" charset="-122"/>
@@ -6714,15 +6714,15 @@
           </a:xfrm>
           <a:prstGeom prst="roundRect">
             <a:avLst>
-              <a:gd name="adj" fmla="val 9677"/>
+              <a:gd name="adj" fmla="val 4839"/>
             </a:avLst>
           </a:prstGeom>
           <a:solidFill>
-            <a:srgbClr val="F7F5F2"/>
+            <a:srgbClr val="F4F6F9"/>
           </a:solidFill>
           <a:ln w="12700">
             <a:solidFill>
-              <a:srgbClr val="F7F5F2"/>
+              <a:srgbClr val="F4F6F9"/>
             </a:solidFill>
             <a:prstDash val="solid"/>
           </a:ln>
@@ -6755,7 +6755,7 @@
             <a:r>
               <a:rPr lang="en-US" sz="1400" b="1" dirty="0">
                 <a:solidFill>
-                  <a:srgbClr val="2B2118"/>
+                  <a:srgbClr val="12294A"/>
                 </a:solidFill>
                 <a:latin typeface="Calibri" pitchFamily="34" charset="0"/>
                 <a:ea typeface="Calibri" pitchFamily="34" charset="-122"/>
@@ -6794,7 +6794,7 @@
             <a:r>
               <a:rPr lang="en-US" sz="1100" dirty="0">
                 <a:solidFill>
-                  <a:srgbClr val="6B6259"/>
+                  <a:srgbClr val="5A6472"/>
                 </a:solidFill>
                 <a:latin typeface="Calibri" pitchFamily="34" charset="0"/>
                 <a:ea typeface="Calibri" pitchFamily="34" charset="-122"/>
@@ -6858,15 +6858,15 @@
           </a:xfrm>
           <a:prstGeom prst="roundRect">
             <a:avLst>
-              <a:gd name="adj" fmla="val 9677"/>
+              <a:gd name="adj" fmla="val 4839"/>
             </a:avLst>
           </a:prstGeom>
           <a:solidFill>
-            <a:srgbClr val="F7F5F2"/>
+            <a:srgbClr val="F4F6F9"/>
           </a:solidFill>
           <a:ln w="12700">
             <a:solidFill>
-              <a:srgbClr val="F7F5F2"/>
+              <a:srgbClr val="F4F6F9"/>
             </a:solidFill>
             <a:prstDash val="solid"/>
           </a:ln>
@@ -6899,7 +6899,7 @@
             <a:r>
               <a:rPr lang="en-US" sz="1400" b="1" dirty="0">
                 <a:solidFill>
-                  <a:srgbClr val="2B2118"/>
+                  <a:srgbClr val="12294A"/>
                 </a:solidFill>
                 <a:latin typeface="Calibri" pitchFamily="34" charset="0"/>
                 <a:ea typeface="Calibri" pitchFamily="34" charset="-122"/>
@@ -6938,7 +6938,7 @@
             <a:r>
               <a:rPr lang="en-US" sz="1100" dirty="0">
                 <a:solidFill>
-                  <a:srgbClr val="6B6259"/>
+                  <a:srgbClr val="5A6472"/>
                 </a:solidFill>
                 <a:latin typeface="Calibri" pitchFamily="34" charset="0"/>
                 <a:ea typeface="Calibri" pitchFamily="34" charset="-122"/>
@@ -7002,15 +7002,15 @@
           </a:xfrm>
           <a:prstGeom prst="roundRect">
             <a:avLst>
-              <a:gd name="adj" fmla="val 9677"/>
+              <a:gd name="adj" fmla="val 4839"/>
             </a:avLst>
           </a:prstGeom>
           <a:solidFill>
-            <a:srgbClr val="F7F5F2"/>
+            <a:srgbClr val="F4F6F9"/>
           </a:solidFill>
           <a:ln w="12700">
             <a:solidFill>
-              <a:srgbClr val="F7F5F2"/>
+              <a:srgbClr val="F4F6F9"/>
             </a:solidFill>
             <a:prstDash val="solid"/>
           </a:ln>
@@ -7043,7 +7043,7 @@
             <a:r>
               <a:rPr lang="en-US" sz="1400" b="1" dirty="0">
                 <a:solidFill>
-                  <a:srgbClr val="2B2118"/>
+                  <a:srgbClr val="12294A"/>
                 </a:solidFill>
                 <a:latin typeface="Calibri" pitchFamily="34" charset="0"/>
                 <a:ea typeface="Calibri" pitchFamily="34" charset="-122"/>
@@ -7082,7 +7082,7 @@
             <a:r>
               <a:rPr lang="en-US" sz="1100" dirty="0">
                 <a:solidFill>
-                  <a:srgbClr val="6B6259"/>
+                  <a:srgbClr val="5A6472"/>
                 </a:solidFill>
                 <a:latin typeface="Calibri" pitchFamily="34" charset="0"/>
                 <a:ea typeface="Calibri" pitchFamily="34" charset="-122"/>
@@ -7146,15 +7146,15 @@
           </a:xfrm>
           <a:prstGeom prst="roundRect">
             <a:avLst>
-              <a:gd name="adj" fmla="val 1807"/>
+              <a:gd name="adj" fmla="val 904"/>
             </a:avLst>
           </a:prstGeom>
           <a:solidFill>
-            <a:srgbClr val="2B2118"/>
+            <a:srgbClr val="12294A"/>
           </a:solidFill>
           <a:ln w="12700">
             <a:solidFill>
-              <a:srgbClr val="2B2118"/>
+              <a:srgbClr val="12294A"/>
             </a:solidFill>
             <a:prstDash val="solid"/>
           </a:ln>
@@ -7187,7 +7187,7 @@
             <a:r>
               <a:rPr lang="en-US" sz="1200" b="1" spc="300" kern="0" dirty="0">
                 <a:solidFill>
-                  <a:srgbClr val="C87F2A"/>
+                  <a:srgbClr val="8FB3DE"/>
                 </a:solidFill>
                 <a:latin typeface="Calibri" pitchFamily="34" charset="0"/>
                 <a:ea typeface="Calibri" pitchFamily="34" charset="-122"/>
@@ -7226,7 +7226,7 @@
             <a:r>
               <a:rPr lang="en-US" sz="4400" b="1" dirty="0">
                 <a:solidFill>
-                  <a:srgbClr val="FF7B6B"/>
+                  <a:srgbClr val="FF8A80"/>
                 </a:solidFill>
                 <a:latin typeface="Cambria" pitchFamily="34" charset="0"/>
                 <a:ea typeface="Cambria" pitchFamily="34" charset="-122"/>
@@ -7307,7 +7307,7 @@
             <a:r>
               <a:rPr lang="en-US" sz="1200" dirty="0">
                 <a:solidFill>
-                  <a:srgbClr val="EFD9B8"/>
+                  <a:srgbClr val="D6E2F0"/>
                 </a:solidFill>
                 <a:latin typeface="Calibri" pitchFamily="34" charset="0"/>
                 <a:ea typeface="Calibri" pitchFamily="34" charset="-122"/>
@@ -7327,7 +7327,7 @@
             <a:r>
               <a:rPr lang="en-US" sz="1200" dirty="0">
                 <a:solidFill>
-                  <a:srgbClr val="EFD9B8"/>
+                  <a:srgbClr val="D6E2F0"/>
                 </a:solidFill>
                 <a:latin typeface="Calibri" pitchFamily="34" charset="0"/>
                 <a:ea typeface="Calibri" pitchFamily="34" charset="-122"/>
@@ -7366,7 +7366,7 @@
             <a:r>
               <a:rPr lang="en-US" sz="1200" dirty="0">
                 <a:solidFill>
-                  <a:srgbClr val="EFD9B8"/>
+                  <a:srgbClr val="D6E2F0"/>
                 </a:solidFill>
                 <a:latin typeface="Calibri" pitchFamily="34" charset="0"/>
                 <a:ea typeface="Calibri" pitchFamily="34" charset="-122"/>
@@ -7405,7 +7405,7 @@
             <a:r>
               <a:rPr lang="en-US" sz="900" dirty="0">
                 <a:solidFill>
-                  <a:srgbClr val="A79E93"/>
+                  <a:srgbClr val="98A2B0"/>
                 </a:solidFill>
                 <a:latin typeface="Calibri" pitchFamily="34" charset="0"/>
                 <a:ea typeface="Calibri" pitchFamily="34" charset="-122"/>
@@ -7444,7 +7444,7 @@
             <a:r>
               <a:rPr lang="en-US" sz="900" dirty="0">
                 <a:solidFill>
-                  <a:srgbClr val="A79E93"/>
+                  <a:srgbClr val="98A2B0"/>
                 </a:solidFill>
                 <a:latin typeface="Calibri" pitchFamily="34" charset="0"/>
                 <a:ea typeface="Calibri" pitchFamily="34" charset="-122"/>
@@ -7508,7 +7508,7 @@
             <a:r>
               <a:rPr lang="en-US" sz="3200" b="1" dirty="0">
                 <a:solidFill>
-                  <a:srgbClr val="2B2118"/>
+                  <a:srgbClr val="12294A"/>
                 </a:solidFill>
                 <a:latin typeface="Cambria" pitchFamily="34" charset="0"/>
                 <a:ea typeface="Cambria" pitchFamily="34" charset="-122"/>
@@ -7547,7 +7547,7 @@
             <a:r>
               <a:rPr lang="en-US" sz="1400" dirty="0">
                 <a:solidFill>
-                  <a:srgbClr val="6B6259"/>
+                  <a:srgbClr val="5A6472"/>
                 </a:solidFill>
                 <a:latin typeface="Calibri" pitchFamily="34" charset="0"/>
                 <a:ea typeface="Calibri" pitchFamily="34" charset="-122"/>
@@ -7572,15 +7572,15 @@
           </a:xfrm>
           <a:prstGeom prst="roundRect">
             <a:avLst>
-              <a:gd name="adj" fmla="val 5882"/>
+              <a:gd name="adj" fmla="val 2941"/>
             </a:avLst>
           </a:prstGeom>
           <a:solidFill>
-            <a:srgbClr val="F7F5F2"/>
+            <a:srgbClr val="F4F6F9"/>
           </a:solidFill>
           <a:ln w="12700">
             <a:solidFill>
-              <a:srgbClr val="F7F5F2"/>
+              <a:srgbClr val="F4F6F9"/>
             </a:solidFill>
             <a:prstDash val="solid"/>
           </a:ln>
@@ -7601,7 +7601,7 @@
             <a:avLst/>
           </a:prstGeom>
           <a:solidFill>
-            <a:srgbClr val="C87F2A"/>
+            <a:srgbClr val="3E6CA3"/>
           </a:solidFill>
           <a:ln/>
         </p:spPr>
@@ -7672,7 +7672,7 @@
             <a:r>
               <a:rPr lang="en-US" sz="1900" b="1" dirty="0">
                 <a:solidFill>
-                  <a:srgbClr val="2B2118"/>
+                  <a:srgbClr val="12294A"/>
                 </a:solidFill>
                 <a:latin typeface="Cambria" pitchFamily="34" charset="0"/>
                 <a:ea typeface="Cambria" pitchFamily="34" charset="-122"/>
@@ -7711,7 +7711,7 @@
             <a:r>
               <a:rPr lang="en-US" sz="1300" dirty="0">
                 <a:solidFill>
-                  <a:srgbClr val="6B6259"/>
+                  <a:srgbClr val="5A6472"/>
                 </a:solidFill>
                 <a:latin typeface="Calibri" pitchFamily="34" charset="0"/>
                 <a:ea typeface="Calibri" pitchFamily="34" charset="-122"/>
@@ -7775,15 +7775,15 @@
           </a:xfrm>
           <a:prstGeom prst="roundRect">
             <a:avLst>
-              <a:gd name="adj" fmla="val 5882"/>
+              <a:gd name="adj" fmla="val 2941"/>
             </a:avLst>
           </a:prstGeom>
           <a:solidFill>
-            <a:srgbClr val="F7F5F2"/>
+            <a:srgbClr val="F4F6F9"/>
           </a:solidFill>
           <a:ln w="12700">
             <a:solidFill>
-              <a:srgbClr val="F7F5F2"/>
+              <a:srgbClr val="F4F6F9"/>
             </a:solidFill>
             <a:prstDash val="solid"/>
           </a:ln>
@@ -7804,7 +7804,7 @@
             <a:avLst/>
           </a:prstGeom>
           <a:solidFill>
-            <a:srgbClr val="C87F2A"/>
+            <a:srgbClr val="3E6CA3"/>
           </a:solidFill>
           <a:ln/>
         </p:spPr>
@@ -7875,7 +7875,7 @@
             <a:r>
               <a:rPr lang="en-US" sz="1900" b="1" dirty="0">
                 <a:solidFill>
-                  <a:srgbClr val="2B2118"/>
+                  <a:srgbClr val="12294A"/>
                 </a:solidFill>
                 <a:latin typeface="Cambria" pitchFamily="34" charset="0"/>
                 <a:ea typeface="Cambria" pitchFamily="34" charset="-122"/>
@@ -7914,7 +7914,7 @@
             <a:r>
               <a:rPr lang="en-US" sz="1300" dirty="0">
                 <a:solidFill>
-                  <a:srgbClr val="6B6259"/>
+                  <a:srgbClr val="5A6472"/>
                 </a:solidFill>
                 <a:latin typeface="Calibri" pitchFamily="34" charset="0"/>
                 <a:ea typeface="Calibri" pitchFamily="34" charset="-122"/>
@@ -7953,7 +7953,7 @@
             <a:r>
               <a:rPr lang="en-US" sz="1800" b="1" dirty="0">
                 <a:solidFill>
-                  <a:srgbClr val="6B6259"/>
+                  <a:srgbClr val="5A6472"/>
                 </a:solidFill>
                 <a:latin typeface="Calibri" pitchFamily="34" charset="0"/>
                 <a:ea typeface="Calibri" pitchFamily="34" charset="-122"/>
@@ -7978,15 +7978,15 @@
           </a:xfrm>
           <a:prstGeom prst="roundRect">
             <a:avLst>
-              <a:gd name="adj" fmla="val 5882"/>
+              <a:gd name="adj" fmla="val 2941"/>
             </a:avLst>
           </a:prstGeom>
           <a:solidFill>
-            <a:srgbClr val="F7F5F2"/>
+            <a:srgbClr val="F4F6F9"/>
           </a:solidFill>
           <a:ln w="12700">
             <a:solidFill>
-              <a:srgbClr val="F7F5F2"/>
+              <a:srgbClr val="F4F6F9"/>
             </a:solidFill>
             <a:prstDash val="solid"/>
           </a:ln>
@@ -8007,7 +8007,7 @@
             <a:avLst/>
           </a:prstGeom>
           <a:solidFill>
-            <a:srgbClr val="C87F2A"/>
+            <a:srgbClr val="3E6CA3"/>
           </a:solidFill>
           <a:ln/>
         </p:spPr>
@@ -8078,7 +8078,7 @@
             <a:r>
               <a:rPr lang="en-US" sz="1900" b="1" dirty="0">
                 <a:solidFill>
-                  <a:srgbClr val="2B2118"/>
+                  <a:srgbClr val="12294A"/>
                 </a:solidFill>
                 <a:latin typeface="Cambria" pitchFamily="34" charset="0"/>
                 <a:ea typeface="Cambria" pitchFamily="34" charset="-122"/>
@@ -8117,7 +8117,7 @@
             <a:r>
               <a:rPr lang="en-US" sz="1300" dirty="0">
                 <a:solidFill>
-                  <a:srgbClr val="6B6259"/>
+                  <a:srgbClr val="5A6472"/>
                 </a:solidFill>
                 <a:latin typeface="Calibri" pitchFamily="34" charset="0"/>
                 <a:ea typeface="Calibri" pitchFamily="34" charset="-122"/>
@@ -8156,7 +8156,7 @@
             <a:r>
               <a:rPr lang="en-US" sz="1800" b="1" dirty="0">
                 <a:solidFill>
-                  <a:srgbClr val="2E6F40"/>
+                  <a:srgbClr val="1E6B3A"/>
                 </a:solidFill>
                 <a:latin typeface="Calibri" pitchFamily="34" charset="0"/>
                 <a:ea typeface="Calibri" pitchFamily="34" charset="-122"/>
@@ -8181,15 +8181,15 @@
           </a:xfrm>
           <a:prstGeom prst="roundRect">
             <a:avLst>
-              <a:gd name="adj" fmla="val 5882"/>
+              <a:gd name="adj" fmla="val 2941"/>
             </a:avLst>
           </a:prstGeom>
           <a:solidFill>
-            <a:srgbClr val="EFD9B8"/>
+            <a:srgbClr val="D6E2F0"/>
           </a:solidFill>
           <a:ln w="12700">
             <a:solidFill>
-              <a:srgbClr val="EFD9B8"/>
+              <a:srgbClr val="D6E2F0"/>
             </a:solidFill>
             <a:prstDash val="solid"/>
           </a:ln>
@@ -8210,7 +8210,7 @@
             <a:avLst/>
           </a:prstGeom>
           <a:solidFill>
-            <a:srgbClr val="2B2118"/>
+            <a:srgbClr val="12294A"/>
           </a:solidFill>
           <a:ln/>
         </p:spPr>
@@ -8281,7 +8281,7 @@
             <a:r>
               <a:rPr lang="en-US" sz="1900" b="1" dirty="0">
                 <a:solidFill>
-                  <a:srgbClr val="2B2118"/>
+                  <a:srgbClr val="12294A"/>
                 </a:solidFill>
                 <a:latin typeface="Cambria" pitchFamily="34" charset="0"/>
                 <a:ea typeface="Cambria" pitchFamily="34" charset="-122"/>
@@ -8320,7 +8320,7 @@
             <a:r>
               <a:rPr lang="en-US" sz="1300" dirty="0">
                 <a:solidFill>
-                  <a:srgbClr val="6B6259"/>
+                  <a:srgbClr val="5A6472"/>
                 </a:solidFill>
                 <a:latin typeface="Calibri" pitchFamily="34" charset="0"/>
                 <a:ea typeface="Calibri" pitchFamily="34" charset="-122"/>
@@ -8359,7 +8359,7 @@
             <a:r>
               <a:rPr lang="en-US" sz="1800" b="1" dirty="0">
                 <a:solidFill>
-                  <a:srgbClr val="2E6F40"/>
+                  <a:srgbClr val="1E6B3A"/>
                 </a:solidFill>
                 <a:latin typeface="Calibri" pitchFamily="34" charset="0"/>
                 <a:ea typeface="Calibri" pitchFamily="34" charset="-122"/>
@@ -8398,7 +8398,7 @@
             <a:r>
               <a:rPr lang="en-US" sz="900" dirty="0">
                 <a:solidFill>
-                  <a:srgbClr val="A79E93"/>
+                  <a:srgbClr val="98A2B0"/>
                 </a:solidFill>
                 <a:latin typeface="Calibri" pitchFamily="34" charset="0"/>
                 <a:ea typeface="Calibri" pitchFamily="34" charset="-122"/>
@@ -8437,7 +8437,7 @@
             <a:r>
               <a:rPr lang="en-US" sz="900" dirty="0">
                 <a:solidFill>
-                  <a:srgbClr val="A79E93"/>
+                  <a:srgbClr val="98A2B0"/>
                 </a:solidFill>
                 <a:latin typeface="Calibri" pitchFamily="34" charset="0"/>
                 <a:ea typeface="Calibri" pitchFamily="34" charset="-122"/>
@@ -8501,7 +8501,7 @@
             <a:r>
               <a:rPr lang="en-US" sz="3200" b="1" dirty="0">
                 <a:solidFill>
-                  <a:srgbClr val="2B2118"/>
+                  <a:srgbClr val="12294A"/>
                 </a:solidFill>
                 <a:latin typeface="Cambria" pitchFamily="34" charset="0"/>
                 <a:ea typeface="Cambria" pitchFamily="34" charset="-122"/>
@@ -8540,7 +8540,7 @@
             <a:r>
               <a:rPr lang="en-US" sz="1400" dirty="0">
                 <a:solidFill>
-                  <a:srgbClr val="6B6259"/>
+                  <a:srgbClr val="5A6472"/>
                 </a:solidFill>
                 <a:latin typeface="Calibri" pitchFamily="34" charset="0"/>
                 <a:ea typeface="Calibri" pitchFamily="34" charset="-122"/>
@@ -8565,15 +8565,15 @@
           </a:xfrm>
           <a:prstGeom prst="roundRect">
             <a:avLst>
-              <a:gd name="adj" fmla="val 1690"/>
+              <a:gd name="adj" fmla="val 845"/>
             </a:avLst>
           </a:prstGeom>
           <a:solidFill>
-            <a:srgbClr val="2B2118"/>
+            <a:srgbClr val="12294A"/>
           </a:solidFill>
           <a:ln w="12700">
             <a:solidFill>
-              <a:srgbClr val="2B2118"/>
+              <a:srgbClr val="12294A"/>
             </a:solidFill>
             <a:prstDash val="solid"/>
           </a:ln>
@@ -8594,7 +8594,7 @@
             <a:avLst/>
           </a:prstGeom>
           <a:solidFill>
-            <a:srgbClr val="C87F2A"/>
+            <a:srgbClr val="3E6CA3"/>
           </a:solidFill>
           <a:ln/>
         </p:spPr>
@@ -8708,7 +8708,7 @@
             <a:r>
               <a:rPr lang="en-US" sz="1250" dirty="0">
                 <a:solidFill>
-                  <a:srgbClr val="EFD9B8"/>
+                  <a:srgbClr val="D6E2F0"/>
                 </a:solidFill>
                 <a:latin typeface="Calibri" pitchFamily="34" charset="0"/>
                 <a:ea typeface="Calibri" pitchFamily="34" charset="-122"/>
@@ -8729,7 +8729,7 @@
             <a:r>
               <a:rPr lang="en-US" sz="1250" dirty="0">
                 <a:solidFill>
-                  <a:srgbClr val="EFD9B8"/>
+                  <a:srgbClr val="D6E2F0"/>
                 </a:solidFill>
                 <a:latin typeface="Calibri" pitchFamily="34" charset="0"/>
                 <a:ea typeface="Calibri" pitchFamily="34" charset="-122"/>
@@ -8750,7 +8750,7 @@
             <a:r>
               <a:rPr lang="en-US" sz="1250" dirty="0">
                 <a:solidFill>
-                  <a:srgbClr val="EFD9B8"/>
+                  <a:srgbClr val="D6E2F0"/>
                 </a:solidFill>
                 <a:latin typeface="Calibri" pitchFamily="34" charset="0"/>
                 <a:ea typeface="Calibri" pitchFamily="34" charset="-122"/>
@@ -8775,15 +8775,15 @@
           </a:xfrm>
           <a:prstGeom prst="roundRect">
             <a:avLst>
-              <a:gd name="adj" fmla="val 1690"/>
+              <a:gd name="adj" fmla="val 845"/>
             </a:avLst>
           </a:prstGeom>
           <a:solidFill>
-            <a:srgbClr val="F7F5F2"/>
+            <a:srgbClr val="F4F6F9"/>
           </a:solidFill>
           <a:ln w="12700">
             <a:solidFill>
-              <a:srgbClr val="F7F5F2"/>
+              <a:srgbClr val="F4F6F9"/>
             </a:solidFill>
             <a:prstDash val="solid"/>
           </a:ln>
@@ -8804,7 +8804,7 @@
             <a:avLst/>
           </a:prstGeom>
           <a:solidFill>
-            <a:srgbClr val="C87F2A"/>
+            <a:srgbClr val="3E6CA3"/>
           </a:solidFill>
           <a:ln/>
         </p:spPr>
@@ -8875,7 +8875,7 @@
             <a:r>
               <a:rPr lang="en-US" sz="1800" b="1" dirty="0">
                 <a:solidFill>
-                  <a:srgbClr val="2B2118"/>
+                  <a:srgbClr val="12294A"/>
                 </a:solidFill>
                 <a:latin typeface="Cambria" pitchFamily="34" charset="0"/>
                 <a:ea typeface="Cambria" pitchFamily="34" charset="-122"/>
@@ -8918,7 +8918,7 @@
             <a:r>
               <a:rPr lang="en-US" sz="1250" dirty="0">
                 <a:solidFill>
-                  <a:srgbClr val="6B6259"/>
+                  <a:srgbClr val="5A6472"/>
                 </a:solidFill>
                 <a:latin typeface="Calibri" pitchFamily="34" charset="0"/>
                 <a:ea typeface="Calibri" pitchFamily="34" charset="-122"/>
@@ -8939,7 +8939,7 @@
             <a:r>
               <a:rPr lang="en-US" sz="1250" dirty="0">
                 <a:solidFill>
-                  <a:srgbClr val="6B6259"/>
+                  <a:srgbClr val="5A6472"/>
                 </a:solidFill>
                 <a:latin typeface="Calibri" pitchFamily="34" charset="0"/>
                 <a:ea typeface="Calibri" pitchFamily="34" charset="-122"/>
@@ -8960,7 +8960,7 @@
             <a:r>
               <a:rPr lang="en-US" sz="1250" dirty="0">
                 <a:solidFill>
-                  <a:srgbClr val="6B6259"/>
+                  <a:srgbClr val="5A6472"/>
                 </a:solidFill>
                 <a:latin typeface="Calibri" pitchFamily="34" charset="0"/>
                 <a:ea typeface="Calibri" pitchFamily="34" charset="-122"/>
@@ -8985,15 +8985,15 @@
           </a:xfrm>
           <a:prstGeom prst="roundRect">
             <a:avLst>
-              <a:gd name="adj" fmla="val 1690"/>
+              <a:gd name="adj" fmla="val 845"/>
             </a:avLst>
           </a:prstGeom>
           <a:solidFill>
-            <a:srgbClr val="F7F5F2"/>
+            <a:srgbClr val="F4F6F9"/>
           </a:solidFill>
           <a:ln w="12700">
             <a:solidFill>
-              <a:srgbClr val="F7F5F2"/>
+              <a:srgbClr val="F4F6F9"/>
             </a:solidFill>
             <a:prstDash val="solid"/>
           </a:ln>
@@ -9014,7 +9014,7 @@
             <a:avLst/>
           </a:prstGeom>
           <a:solidFill>
-            <a:srgbClr val="C87F2A"/>
+            <a:srgbClr val="3E6CA3"/>
           </a:solidFill>
           <a:ln/>
         </p:spPr>
@@ -9085,7 +9085,7 @@
             <a:r>
               <a:rPr lang="en-US" sz="1800" b="1" dirty="0">
                 <a:solidFill>
-                  <a:srgbClr val="2B2118"/>
+                  <a:srgbClr val="12294A"/>
                 </a:solidFill>
                 <a:latin typeface="Cambria" pitchFamily="34" charset="0"/>
                 <a:ea typeface="Cambria" pitchFamily="34" charset="-122"/>
@@ -9128,7 +9128,7 @@
             <a:r>
               <a:rPr lang="en-US" sz="1250" dirty="0">
                 <a:solidFill>
-                  <a:srgbClr val="6B6259"/>
+                  <a:srgbClr val="5A6472"/>
                 </a:solidFill>
                 <a:latin typeface="Calibri" pitchFamily="34" charset="0"/>
                 <a:ea typeface="Calibri" pitchFamily="34" charset="-122"/>
@@ -9149,7 +9149,7 @@
             <a:r>
               <a:rPr lang="en-US" sz="1250" dirty="0">
                 <a:solidFill>
-                  <a:srgbClr val="6B6259"/>
+                  <a:srgbClr val="5A6472"/>
                 </a:solidFill>
                 <a:latin typeface="Calibri" pitchFamily="34" charset="0"/>
                 <a:ea typeface="Calibri" pitchFamily="34" charset="-122"/>
@@ -9170,7 +9170,7 @@
             <a:r>
               <a:rPr lang="en-US" sz="1250" dirty="0">
                 <a:solidFill>
-                  <a:srgbClr val="6B6259"/>
+                  <a:srgbClr val="5A6472"/>
                 </a:solidFill>
                 <a:latin typeface="Calibri" pitchFamily="34" charset="0"/>
                 <a:ea typeface="Calibri" pitchFamily="34" charset="-122"/>
@@ -9209,7 +9209,7 @@
             <a:r>
               <a:rPr lang="en-US" sz="900" dirty="0">
                 <a:solidFill>
-                  <a:srgbClr val="A79E93"/>
+                  <a:srgbClr val="98A2B0"/>
                 </a:solidFill>
                 <a:latin typeface="Calibri" pitchFamily="34" charset="0"/>
                 <a:ea typeface="Calibri" pitchFamily="34" charset="-122"/>
@@ -9248,7 +9248,7 @@
             <a:r>
               <a:rPr lang="en-US" sz="900" dirty="0">
                 <a:solidFill>
-                  <a:srgbClr val="A79E93"/>
+                  <a:srgbClr val="98A2B0"/>
                 </a:solidFill>
                 <a:latin typeface="Calibri" pitchFamily="34" charset="0"/>
                 <a:ea typeface="Calibri" pitchFamily="34" charset="-122"/>
@@ -9312,7 +9312,7 @@
             <a:r>
               <a:rPr lang="en-US" sz="3200" b="1" dirty="0">
                 <a:solidFill>
-                  <a:srgbClr val="2B2118"/>
+                  <a:srgbClr val="12294A"/>
                 </a:solidFill>
                 <a:latin typeface="Cambria" pitchFamily="34" charset="0"/>
                 <a:ea typeface="Cambria" pitchFamily="34" charset="-122"/>
@@ -9351,7 +9351,7 @@
             <a:r>
               <a:rPr lang="en-US" sz="1400" dirty="0">
                 <a:solidFill>
-                  <a:srgbClr val="6B6259"/>
+                  <a:srgbClr val="5A6472"/>
                 </a:solidFill>
                 <a:latin typeface="Calibri" pitchFamily="34" charset="0"/>
                 <a:ea typeface="Calibri" pitchFamily="34" charset="-122"/>
@@ -9376,15 +9376,15 @@
           </a:xfrm>
           <a:prstGeom prst="roundRect">
             <a:avLst>
-              <a:gd name="adj" fmla="val 4918"/>
+              <a:gd name="adj" fmla="val 2459"/>
             </a:avLst>
           </a:prstGeom>
           <a:solidFill>
-            <a:srgbClr val="F7F5F2"/>
+            <a:srgbClr val="F4F6F9"/>
           </a:solidFill>
           <a:ln w="12700">
             <a:solidFill>
-              <a:srgbClr val="F7F5F2"/>
+              <a:srgbClr val="F4F6F9"/>
             </a:solidFill>
             <a:prstDash val="solid"/>
           </a:ln>
@@ -9405,7 +9405,7 @@
             <a:avLst/>
           </a:prstGeom>
           <a:solidFill>
-            <a:srgbClr val="6B6259"/>
+            <a:srgbClr val="5A6472"/>
           </a:solidFill>
           <a:ln/>
         </p:spPr>
@@ -9476,7 +9476,7 @@
             <a:r>
               <a:rPr lang="en-US" sz="1800" b="1" dirty="0">
                 <a:solidFill>
-                  <a:srgbClr val="2B2118"/>
+                  <a:srgbClr val="12294A"/>
                 </a:solidFill>
                 <a:latin typeface="Cambria" pitchFamily="34" charset="0"/>
                 <a:ea typeface="Cambria" pitchFamily="34" charset="-122"/>
@@ -9518,7 +9518,7 @@
             <a:r>
               <a:rPr lang="en-US" sz="1300" dirty="0">
                 <a:solidFill>
-                  <a:srgbClr val="6B6259"/>
+                  <a:srgbClr val="5A6472"/>
                 </a:solidFill>
                 <a:latin typeface="Calibri" pitchFamily="34" charset="0"/>
                 <a:ea typeface="Calibri" pitchFamily="34" charset="-122"/>
@@ -9582,15 +9582,15 @@
           </a:xfrm>
           <a:prstGeom prst="roundRect">
             <a:avLst>
-              <a:gd name="adj" fmla="val 4918"/>
+              <a:gd name="adj" fmla="val 2459"/>
             </a:avLst>
           </a:prstGeom>
           <a:solidFill>
-            <a:srgbClr val="F7F5F2"/>
+            <a:srgbClr val="F4F6F9"/>
           </a:solidFill>
           <a:ln w="12700">
             <a:solidFill>
-              <a:srgbClr val="F7F5F2"/>
+              <a:srgbClr val="F4F6F9"/>
             </a:solidFill>
             <a:prstDash val="solid"/>
           </a:ln>
@@ -9611,7 +9611,7 @@
             <a:avLst/>
           </a:prstGeom>
           <a:solidFill>
-            <a:srgbClr val="6B6259"/>
+            <a:srgbClr val="5A6472"/>
           </a:solidFill>
           <a:ln/>
         </p:spPr>
@@ -9682,7 +9682,7 @@
             <a:r>
               <a:rPr lang="en-US" sz="1800" b="1" dirty="0">
                 <a:solidFill>
-                  <a:srgbClr val="2B2118"/>
+                  <a:srgbClr val="12294A"/>
                 </a:solidFill>
                 <a:latin typeface="Cambria" pitchFamily="34" charset="0"/>
                 <a:ea typeface="Cambria" pitchFamily="34" charset="-122"/>
@@ -9724,7 +9724,7 @@
             <a:r>
               <a:rPr lang="en-US" sz="1300" dirty="0">
                 <a:solidFill>
-                  <a:srgbClr val="6B6259"/>
+                  <a:srgbClr val="5A6472"/>
                 </a:solidFill>
                 <a:latin typeface="Calibri" pitchFamily="34" charset="0"/>
                 <a:ea typeface="Calibri" pitchFamily="34" charset="-122"/>
@@ -9763,7 +9763,7 @@
             <a:r>
               <a:rPr lang="en-US" sz="1700" b="1" dirty="0">
                 <a:solidFill>
-                  <a:srgbClr val="6B6259"/>
+                  <a:srgbClr val="5A6472"/>
                 </a:solidFill>
                 <a:latin typeface="Calibri" pitchFamily="34" charset="0"/>
                 <a:ea typeface="Calibri" pitchFamily="34" charset="-122"/>
@@ -9788,15 +9788,15 @@
           </a:xfrm>
           <a:prstGeom prst="roundRect">
             <a:avLst>
-              <a:gd name="adj" fmla="val 4918"/>
+              <a:gd name="adj" fmla="val 2459"/>
             </a:avLst>
           </a:prstGeom>
           <a:solidFill>
-            <a:srgbClr val="F7F5F2"/>
+            <a:srgbClr val="F4F6F9"/>
           </a:solidFill>
           <a:ln w="12700">
             <a:solidFill>
-              <a:srgbClr val="F7F5F2"/>
+              <a:srgbClr val="F4F6F9"/>
             </a:solidFill>
             <a:prstDash val="solid"/>
           </a:ln>
@@ -9817,7 +9817,7 @@
             <a:avLst/>
           </a:prstGeom>
           <a:solidFill>
-            <a:srgbClr val="6B6259"/>
+            <a:srgbClr val="5A6472"/>
           </a:solidFill>
           <a:ln/>
         </p:spPr>
@@ -9888,7 +9888,7 @@
             <a:r>
               <a:rPr lang="en-US" sz="1800" b="1" dirty="0">
                 <a:solidFill>
-                  <a:srgbClr val="2B2118"/>
+                  <a:srgbClr val="12294A"/>
                 </a:solidFill>
                 <a:latin typeface="Cambria" pitchFamily="34" charset="0"/>
                 <a:ea typeface="Cambria" pitchFamily="34" charset="-122"/>
@@ -9930,7 +9930,7 @@
             <a:r>
               <a:rPr lang="en-US" sz="1300" dirty="0">
                 <a:solidFill>
-                  <a:srgbClr val="6B6259"/>
+                  <a:srgbClr val="5A6472"/>
                 </a:solidFill>
                 <a:latin typeface="Calibri" pitchFamily="34" charset="0"/>
                 <a:ea typeface="Calibri" pitchFamily="34" charset="-122"/>
@@ -9969,7 +9969,7 @@
             <a:r>
               <a:rPr lang="en-US" sz="1700" b="1" dirty="0">
                 <a:solidFill>
-                  <a:srgbClr val="6B6259"/>
+                  <a:srgbClr val="5A6472"/>
                 </a:solidFill>
                 <a:latin typeface="Calibri" pitchFamily="34" charset="0"/>
                 <a:ea typeface="Calibri" pitchFamily="34" charset="-122"/>
@@ -10008,7 +10008,7 @@
             <a:r>
               <a:rPr lang="en-US" sz="900" dirty="0">
                 <a:solidFill>
-                  <a:srgbClr val="A79E93"/>
+                  <a:srgbClr val="98A2B0"/>
                 </a:solidFill>
                 <a:latin typeface="Calibri" pitchFamily="34" charset="0"/>
                 <a:ea typeface="Calibri" pitchFamily="34" charset="-122"/>
@@ -10047,7 +10047,7 @@
             <a:r>
               <a:rPr lang="en-US" sz="900" dirty="0">
                 <a:solidFill>
-                  <a:srgbClr val="A79E93"/>
+                  <a:srgbClr val="98A2B0"/>
                 </a:solidFill>
                 <a:latin typeface="Calibri" pitchFamily="34" charset="0"/>
                 <a:ea typeface="Calibri" pitchFamily="34" charset="-122"/>
@@ -10073,7 +10073,7 @@
     <p:bg>
       <p:bgPr>
         <a:solidFill>
-          <a:srgbClr val="2B2118"/>
+          <a:srgbClr val="12294A"/>
         </a:solidFill>
       </p:bgPr>
     </p:bg>
@@ -10118,7 +10118,7 @@
             <a:r>
               <a:rPr lang="en-US" sz="1300" b="1" spc="500" kern="0" dirty="0">
                 <a:solidFill>
-                  <a:srgbClr val="C87F2A"/>
+                  <a:srgbClr val="8FB3DE"/>
                 </a:solidFill>
                 <a:latin typeface="Calibri" pitchFamily="34" charset="0"/>
                 <a:ea typeface="Calibri" pitchFamily="34" charset="-122"/>
@@ -10196,7 +10196,7 @@
             <a:r>
               <a:rPr lang="en-US" sz="1100" b="1" spc="200" kern="0" dirty="0">
                 <a:solidFill>
-                  <a:srgbClr val="C87F2A"/>
+                  <a:srgbClr val="8FB3DE"/>
                 </a:solidFill>
                 <a:latin typeface="Calibri" pitchFamily="34" charset="0"/>
                 <a:ea typeface="Calibri" pitchFamily="34" charset="-122"/>
@@ -10235,7 +10235,7 @@
             <a:r>
               <a:rPr lang="en-US" sz="2200" strike="sngStrike" dirty="0">
                 <a:solidFill>
-                  <a:srgbClr val="8A8079"/>
+                  <a:srgbClr val="7C8899"/>
                 </a:solidFill>
                 <a:latin typeface="Cambria" pitchFamily="34" charset="0"/>
                 <a:ea typeface="Cambria" pitchFamily="34" charset="-122"/>
@@ -10274,7 +10274,7 @@
             <a:r>
               <a:rPr lang="en-US" sz="2000" dirty="0">
                 <a:solidFill>
-                  <a:srgbClr val="C87F2A"/>
+                  <a:srgbClr val="8FB3DE"/>
                 </a:solidFill>
                 <a:latin typeface="Calibri" pitchFamily="34" charset="0"/>
                 <a:ea typeface="Calibri" pitchFamily="34" charset="-122"/>
@@ -10352,7 +10352,7 @@
             <a:r>
               <a:rPr lang="en-US" sz="1100" b="1" spc="200" kern="0" dirty="0">
                 <a:solidFill>
-                  <a:srgbClr val="C87F2A"/>
+                  <a:srgbClr val="8FB3DE"/>
                 </a:solidFill>
                 <a:latin typeface="Calibri" pitchFamily="34" charset="0"/>
                 <a:ea typeface="Calibri" pitchFamily="34" charset="-122"/>
@@ -10391,7 +10391,7 @@
             <a:r>
               <a:rPr lang="en-US" sz="2200" strike="sngStrike" dirty="0">
                 <a:solidFill>
-                  <a:srgbClr val="8A8079"/>
+                  <a:srgbClr val="7C8899"/>
                 </a:solidFill>
                 <a:latin typeface="Cambria" pitchFamily="34" charset="0"/>
                 <a:ea typeface="Cambria" pitchFamily="34" charset="-122"/>
@@ -10430,7 +10430,7 @@
             <a:r>
               <a:rPr lang="en-US" sz="2000" dirty="0">
                 <a:solidFill>
-                  <a:srgbClr val="C87F2A"/>
+                  <a:srgbClr val="8FB3DE"/>
                 </a:solidFill>
                 <a:latin typeface="Calibri" pitchFamily="34" charset="0"/>
                 <a:ea typeface="Calibri" pitchFamily="34" charset="-122"/>
@@ -10508,7 +10508,7 @@
             <a:r>
               <a:rPr lang="en-US" sz="1100" b="1" spc="200" kern="0" dirty="0">
                 <a:solidFill>
-                  <a:srgbClr val="C87F2A"/>
+                  <a:srgbClr val="8FB3DE"/>
                 </a:solidFill>
                 <a:latin typeface="Calibri" pitchFamily="34" charset="0"/>
                 <a:ea typeface="Calibri" pitchFamily="34" charset="-122"/>
@@ -10547,7 +10547,7 @@
             <a:r>
               <a:rPr lang="en-US" sz="2200" strike="sngStrike" dirty="0">
                 <a:solidFill>
-                  <a:srgbClr val="8A8079"/>
+                  <a:srgbClr val="7C8899"/>
                 </a:solidFill>
                 <a:latin typeface="Cambria" pitchFamily="34" charset="0"/>
                 <a:ea typeface="Cambria" pitchFamily="34" charset="-122"/>
@@ -10586,7 +10586,7 @@
             <a:r>
               <a:rPr lang="en-US" sz="2000" dirty="0">
                 <a:solidFill>
-                  <a:srgbClr val="C87F2A"/>
+                  <a:srgbClr val="8FB3DE"/>
                 </a:solidFill>
                 <a:latin typeface="Calibri" pitchFamily="34" charset="0"/>
                 <a:ea typeface="Calibri" pitchFamily="34" charset="-122"/>
@@ -10667,7 +10667,7 @@
             <a:r>
               <a:rPr lang="en-US" sz="1500" dirty="0">
                 <a:solidFill>
-                  <a:srgbClr val="EFD9B8"/>
+                  <a:srgbClr val="D6E2F0"/>
                 </a:solidFill>
                 <a:latin typeface="Calibri" pitchFamily="34" charset="0"/>
                 <a:ea typeface="Calibri" pitchFamily="34" charset="-122"/>
@@ -10687,7 +10687,7 @@
             <a:r>
               <a:rPr lang="en-US" sz="1500" dirty="0">
                 <a:solidFill>
-                  <a:srgbClr val="EFD9B8"/>
+                  <a:srgbClr val="D6E2F0"/>
                 </a:solidFill>
                 <a:latin typeface="Calibri" pitchFamily="34" charset="0"/>
                 <a:ea typeface="Calibri" pitchFamily="34" charset="-122"/>
@@ -10751,7 +10751,7 @@
             <a:r>
               <a:rPr lang="en-US" sz="3200" b="1" dirty="0">
                 <a:solidFill>
-                  <a:srgbClr val="2B2118"/>
+                  <a:srgbClr val="12294A"/>
                 </a:solidFill>
                 <a:latin typeface="Cambria" pitchFamily="34" charset="0"/>
                 <a:ea typeface="Cambria" pitchFamily="34" charset="-122"/>
@@ -10790,7 +10790,7 @@
             <a:r>
               <a:rPr lang="en-US" sz="1400" dirty="0">
                 <a:solidFill>
-                  <a:srgbClr val="6B6259"/>
+                  <a:srgbClr val="5A6472"/>
                 </a:solidFill>
                 <a:latin typeface="Calibri" pitchFamily="34" charset="0"/>
                 <a:ea typeface="Calibri" pitchFamily="34" charset="-122"/>
@@ -10831,15 +10831,15 @@
           </a:xfrm>
           <a:prstGeom prst="roundRect">
             <a:avLst>
-              <a:gd name="adj" fmla="val 3871"/>
+              <a:gd name="adj" fmla="val 1935"/>
             </a:avLst>
           </a:prstGeom>
           <a:solidFill>
-            <a:srgbClr val="EFD9B8"/>
+            <a:srgbClr val="D6E2F0"/>
           </a:solidFill>
           <a:ln w="12700">
             <a:solidFill>
-              <a:srgbClr val="EFD9B8"/>
+              <a:srgbClr val="D6E2F0"/>
             </a:solidFill>
             <a:prstDash val="solid"/>
           </a:ln>
@@ -10872,7 +10872,7 @@
             <a:r>
               <a:rPr lang="en-US" sz="1100" b="1" spc="200" kern="0" dirty="0">
                 <a:solidFill>
-                  <a:srgbClr val="2B2118"/>
+                  <a:srgbClr val="12294A"/>
                 </a:solidFill>
                 <a:latin typeface="Calibri" pitchFamily="34" charset="0"/>
                 <a:ea typeface="Calibri" pitchFamily="34" charset="-122"/>
@@ -10911,7 +10911,7 @@
             <a:r>
               <a:rPr lang="en-US" sz="3400" b="1" dirty="0">
                 <a:solidFill>
-                  <a:srgbClr val="2B2118"/>
+                  <a:srgbClr val="12294A"/>
                 </a:solidFill>
                 <a:latin typeface="Cambria" pitchFamily="34" charset="0"/>
                 <a:ea typeface="Cambria" pitchFamily="34" charset="-122"/>
@@ -10938,7 +10938,7 @@
             <a:avLst/>
           </a:prstGeom>
           <a:solidFill>
-            <a:srgbClr val="C87F2A"/>
+            <a:srgbClr val="3E6CA3"/>
           </a:solidFill>
           <a:ln/>
         </p:spPr>
@@ -10970,7 +10970,7 @@
             <a:r>
               <a:rPr lang="en-US" sz="1300" b="1" dirty="0">
                 <a:solidFill>
-                  <a:srgbClr val="2B2118"/>
+                  <a:srgbClr val="12294A"/>
                 </a:solidFill>
                 <a:latin typeface="Calibri" pitchFamily="34" charset="0"/>
                 <a:ea typeface="Calibri" pitchFamily="34" charset="-122"/>
@@ -11009,7 +11009,7 @@
             <a:r>
               <a:rPr lang="en-US" sz="1200" dirty="0">
                 <a:solidFill>
-                  <a:srgbClr val="6B6259"/>
+                  <a:srgbClr val="5A6472"/>
                 </a:solidFill>
                 <a:latin typeface="Calibri" pitchFamily="34" charset="0"/>
                 <a:ea typeface="Calibri" pitchFamily="34" charset="-122"/>
@@ -11036,7 +11036,7 @@
             <a:avLst/>
           </a:prstGeom>
           <a:solidFill>
-            <a:srgbClr val="C87F2A"/>
+            <a:srgbClr val="3E6CA3"/>
           </a:solidFill>
           <a:ln/>
         </p:spPr>
@@ -11068,7 +11068,7 @@
             <a:r>
               <a:rPr lang="en-US" sz="1300" b="1" dirty="0">
                 <a:solidFill>
-                  <a:srgbClr val="2B2118"/>
+                  <a:srgbClr val="12294A"/>
                 </a:solidFill>
                 <a:latin typeface="Calibri" pitchFamily="34" charset="0"/>
                 <a:ea typeface="Calibri" pitchFamily="34" charset="-122"/>
@@ -11107,7 +11107,7 @@
             <a:r>
               <a:rPr lang="en-US" sz="1200" dirty="0">
                 <a:solidFill>
-                  <a:srgbClr val="6B6259"/>
+                  <a:srgbClr val="5A6472"/>
                 </a:solidFill>
                 <a:latin typeface="Calibri" pitchFamily="34" charset="0"/>
                 <a:ea typeface="Calibri" pitchFamily="34" charset="-122"/>
@@ -11134,7 +11134,7 @@
             <a:avLst/>
           </a:prstGeom>
           <a:solidFill>
-            <a:srgbClr val="C87F2A"/>
+            <a:srgbClr val="3E6CA3"/>
           </a:solidFill>
           <a:ln/>
         </p:spPr>
@@ -11166,7 +11166,7 @@
             <a:r>
               <a:rPr lang="en-US" sz="1300" b="1" dirty="0">
                 <a:solidFill>
-                  <a:srgbClr val="2B2118"/>
+                  <a:srgbClr val="12294A"/>
                 </a:solidFill>
                 <a:latin typeface="Calibri" pitchFamily="34" charset="0"/>
                 <a:ea typeface="Calibri" pitchFamily="34" charset="-122"/>
@@ -11205,7 +11205,7 @@
             <a:r>
               <a:rPr lang="en-US" sz="1200" dirty="0">
                 <a:solidFill>
-                  <a:srgbClr val="6B6259"/>
+                  <a:srgbClr val="5A6472"/>
                 </a:solidFill>
                 <a:latin typeface="Calibri" pitchFamily="34" charset="0"/>
                 <a:ea typeface="Calibri" pitchFamily="34" charset="-122"/>
@@ -11244,7 +11244,7 @@
             <a:r>
               <a:rPr lang="en-US" sz="900" dirty="0">
                 <a:solidFill>
-                  <a:srgbClr val="A79E93"/>
+                  <a:srgbClr val="98A2B0"/>
                 </a:solidFill>
                 <a:latin typeface="Calibri" pitchFamily="34" charset="0"/>
                 <a:ea typeface="Calibri" pitchFamily="34" charset="-122"/>
@@ -11283,7 +11283,7 @@
             <a:r>
               <a:rPr lang="en-US" sz="900" dirty="0">
                 <a:solidFill>
-                  <a:srgbClr val="A79E93"/>
+                  <a:srgbClr val="98A2B0"/>
                 </a:solidFill>
                 <a:latin typeface="Calibri" pitchFamily="34" charset="0"/>
                 <a:ea typeface="Calibri" pitchFamily="34" charset="-122"/>

</xml_diff>